<commit_message>
docs: publish real device screenshots from git images to README, eliminate placeholders, add demo recordings and presentation assets
</commit_message>
<xml_diff>
--- a/Presentation/NIVARA.pptx
+++ b/Presentation/NIVARA.pptx
@@ -1,9 +1,12 @@
 
 <file path=ppt/presentation.xml><?xml version="1.0" encoding="utf-8"?>
-<p:presentation xmlns:a="http://schemas.openxmlformats.org/drawingml/2006/main" xmlns:r="http://schemas.openxmlformats.org/officeDocument/2006/relationships" xmlns:p="http://schemas.openxmlformats.org/presentationml/2006/main" saveSubsetFonts="true" autoCompressPictures="0" embedTrueTypeFonts="true">
+<p:presentation xmlns:a="http://schemas.openxmlformats.org/drawingml/2006/main" xmlns:r="http://schemas.openxmlformats.org/officeDocument/2006/relationships" xmlns:p="http://schemas.openxmlformats.org/presentationml/2006/main" embedTrueTypeFonts="1" saveSubsetFonts="1" autoCompressPictures="0">
   <p:sldMasterIdLst>
     <p:sldMasterId id="2147483648" r:id="rId1"/>
   </p:sldMasterIdLst>
+  <p:notesMasterIdLst>
+    <p:notesMasterId r:id="rId8"/>
+  </p:notesMasterIdLst>
   <p:sldIdLst>
     <p:sldId id="256" r:id="rId2"/>
     <p:sldId id="257" r:id="rId3"/>
@@ -12,23 +15,20 @@
     <p:sldId id="260" r:id="rId6"/>
     <p:sldId id="261" r:id="rId7"/>
   </p:sldIdLst>
-  <p:notesMasterIdLst>
-    <p:notesMasterId r:id="rId8"/>
-  </p:notesMasterIdLst>
-  <p:sldSz cx="12191695" cy="6858000"/>
-  <p:notesSz cx="6858000" cy="12191695"/>
+  <p:sldSz cx="12192000" cy="6858000"/>
+  <p:notesSz cx="6858000" cy="12192000"/>
   <p:embeddedFontLst>
     <p:embeddedFont>
-      <p:font typeface="Instrument Sans Medium"/>
-      <p:regular r:id="rId201314"/>
+      <p:font typeface="Instrument Sans Bold" panose="020B0604020202020204" charset="0"/>
+      <p:regular r:id="rId9"/>
     </p:embeddedFont>
     <p:embeddedFont>
-      <p:font typeface="Instrument Sans SemiBold"/>
-      <p:regular r:id="rId201315"/>
+      <p:font typeface="Instrument Sans Medium" panose="020B0604020202020204" charset="0"/>
+      <p:regular r:id="rId10"/>
     </p:embeddedFont>
     <p:embeddedFont>
-      <p:font typeface="Instrument Sans Bold"/>
-      <p:regular r:id="rId201316"/>
+      <p:font typeface="Instrument Sans SemiBold" panose="020B0604020202020204" charset="0"/>
+      <p:regular r:id="rId11"/>
     </p:embeddedFont>
   </p:embeddedFontLst>
   <p:defaultTextStyle>
@@ -123,6 +123,11 @@
       </a:defRPr>
     </a:lvl9pPr>
   </p:defaultTextStyle>
+  <p:extLst>
+    <p:ext uri="{EFAFB233-063F-42B5-8137-9DF3F51BA10A}">
+      <p15:sldGuideLst xmlns:p15="http://schemas.microsoft.com/office/powerpoint/2012/main"/>
+    </p:ext>
+  </p:extLst>
 </p:presentation>
 </file>
 
@@ -148,234 +153,10 @@
           <a:chExt cx="0" cy="0"/>
         </a:xfrm>
       </p:grpSpPr>
-      <p:sp>
-        <p:nvSpPr>
-          <p:cNvPr id="2" name="Header Placeholder 1"/>
-          <p:cNvSpPr>
-            <a:spLocks noGrp="1"/>
-          </p:cNvSpPr>
-          <p:nvPr>
-            <p:ph type="hdr" sz="quarter"/>
-          </p:nvPr>
-        </p:nvSpPr>
-        <p:spPr>
-          <a:xfrm>
-            <a:off x="0" y="0"/>
-            <a:ext cx="2971800" cy="458788"/>
-          </a:xfrm>
-          <a:prstGeom prst="rect">
-            <a:avLst/>
-          </a:prstGeom>
-        </p:spPr>
-        <p:txBody>
-          <a:bodyPr vert="horz" lIns="91440" tIns="45720" rIns="91440" bIns="45720" rtlCol="0"/>
-          <a:lstStyle>
-            <a:lvl1pPr algn="l">
-              <a:defRPr sz="1200"/>
-            </a:lvl1pPr>
-          </a:lstStyle>
-          <a:p>
-            <a:endParaRPr lang="en-US"/>
-          </a:p>
-        </p:txBody>
-      </p:sp>
-      <p:sp>
-        <p:nvSpPr>
-          <p:cNvPr id="3" name="Date Placeholder 2"/>
-          <p:cNvSpPr>
-            <a:spLocks noGrp="1"/>
-          </p:cNvSpPr>
-          <p:nvPr>
-            <p:ph type="dt" idx="1"/>
-          </p:nvPr>
-        </p:nvSpPr>
-        <p:spPr>
-          <a:xfrm>
-            <a:off x="3884613" y="0"/>
-            <a:ext cx="2971800" cy="458788"/>
-          </a:xfrm>
-          <a:prstGeom prst="rect">
-            <a:avLst/>
-          </a:prstGeom>
-        </p:spPr>
-        <p:txBody>
-          <a:bodyPr vert="horz" lIns="91440" tIns="45720" rIns="91440" bIns="45720" rtlCol="0"/>
-          <a:lstStyle>
-            <a:lvl1pPr algn="r">
-              <a:defRPr sz="1200"/>
-            </a:lvl1pPr>
-          </a:lstStyle>
-          <a:p>
-            <a:fld id="{5282F153-3F37-0F45-9E97-73ACFA13230C}" type="datetimeFigureOut">
-              <a:rPr lang="en-US"/>
-              <a:t>7/23/19</a:t>
-            </a:fld>
-            <a:endParaRPr lang="en-US"/>
-          </a:p>
-        </p:txBody>
-      </p:sp>
-      <p:sp>
-        <p:nvSpPr>
-          <p:cNvPr id="4" name="Slide Image Placeholder 3"/>
-          <p:cNvSpPr>
-            <a:spLocks noGrp="1" noRot="1" noChangeAspect="1"/>
-          </p:cNvSpPr>
-          <p:nvPr>
-            <p:ph type="sldImg" idx="2"/>
-          </p:nvPr>
-        </p:nvSpPr>
-        <p:spPr>
-          <a:xfrm>
-            <a:off x="685800" y="1143000"/>
-            <a:ext cx="5486400" cy="3086100"/>
-          </a:xfrm>
-          <a:prstGeom prst="rect">
-            <a:avLst/>
-          </a:prstGeom>
-          <a:noFill/>
-          <a:ln w="12700">
-            <a:solidFill>
-              <a:prstClr val="black"/>
-            </a:solidFill>
-          </a:ln>
-        </p:spPr>
-        <p:txBody>
-          <a:bodyPr vert="horz" lIns="91440" tIns="45720" rIns="91440" bIns="45720" rtlCol="0" anchor="ctr"/>
-          <a:lstStyle/>
-          <a:p>
-            <a:endParaRPr lang="en-US"/>
-          </a:p>
-        </p:txBody>
-      </p:sp>
-      <p:sp>
-        <p:nvSpPr>
-          <p:cNvPr id="5" name="Notes Placeholder 4"/>
-          <p:cNvSpPr>
-            <a:spLocks noGrp="1"/>
-          </p:cNvSpPr>
-          <p:nvPr>
-            <p:ph type="body" sz="quarter" idx="3"/>
-          </p:nvPr>
-        </p:nvSpPr>
-        <p:spPr>
-          <a:xfrm>
-            <a:off x="685800" y="4400550"/>
-            <a:ext cx="5486400" cy="3600450"/>
-          </a:xfrm>
-          <a:prstGeom prst="rect">
-            <a:avLst/>
-          </a:prstGeom>
-        </p:spPr>
-        <p:txBody>
-          <a:bodyPr vert="horz" lIns="91440" tIns="45720" rIns="91440" bIns="45720" rtlCol="0"/>
-          <a:lstStyle/>
-          <a:p>
-            <a:pPr lvl="0"/>
-            <a:r>
-              <a:rPr lang="en-US"/>
-              <a:t>Click to edit Master text styles</a:t>
-            </a:r>
-          </a:p>
-          <a:p>
-            <a:pPr lvl="1"/>
-            <a:r>
-              <a:rPr lang="en-US"/>
-              <a:t>Second level</a:t>
-            </a:r>
-          </a:p>
-          <a:p>
-            <a:pPr lvl="2"/>
-            <a:r>
-              <a:rPr lang="en-US"/>
-              <a:t>Third level</a:t>
-            </a:r>
-          </a:p>
-          <a:p>
-            <a:pPr lvl="3"/>
-            <a:r>
-              <a:rPr lang="en-US"/>
-              <a:t>Fourth level</a:t>
-            </a:r>
-          </a:p>
-          <a:p>
-            <a:pPr lvl="4"/>
-            <a:r>
-              <a:rPr lang="en-US"/>
-              <a:t>Fifth level</a:t>
-            </a:r>
-          </a:p>
-        </p:txBody>
-      </p:sp>
-      <p:sp>
-        <p:nvSpPr>
-          <p:cNvPr id="6" name="Footer Placeholder 5"/>
-          <p:cNvSpPr>
-            <a:spLocks noGrp="1"/>
-          </p:cNvSpPr>
-          <p:nvPr>
-            <p:ph type="ftr" sz="quarter" idx="4"/>
-          </p:nvPr>
-        </p:nvSpPr>
-        <p:spPr>
-          <a:xfrm>
-            <a:off x="0" y="8685213"/>
-            <a:ext cx="2971800" cy="458787"/>
-          </a:xfrm>
-          <a:prstGeom prst="rect">
-            <a:avLst/>
-          </a:prstGeom>
-        </p:spPr>
-        <p:txBody>
-          <a:bodyPr vert="horz" lIns="91440" tIns="45720" rIns="91440" bIns="45720" rtlCol="0" anchor="b"/>
-          <a:lstStyle>
-            <a:lvl1pPr algn="l">
-              <a:defRPr sz="1200"/>
-            </a:lvl1pPr>
-          </a:lstStyle>
-          <a:p>
-            <a:endParaRPr lang="en-US"/>
-          </a:p>
-        </p:txBody>
-      </p:sp>
-      <p:sp>
-        <p:nvSpPr>
-          <p:cNvPr id="7" name="Slide Number Placeholder 6"/>
-          <p:cNvSpPr>
-            <a:spLocks noGrp="1"/>
-          </p:cNvSpPr>
-          <p:nvPr>
-            <p:ph type="sldNum" sz="quarter" idx="5"/>
-          </p:nvPr>
-        </p:nvSpPr>
-        <p:spPr>
-          <a:xfrm>
-            <a:off x="3884613" y="8685213"/>
-            <a:ext cx="2971800" cy="458787"/>
-          </a:xfrm>
-          <a:prstGeom prst="rect">
-            <a:avLst/>
-          </a:prstGeom>
-        </p:spPr>
-        <p:txBody>
-          <a:bodyPr vert="horz" lIns="91440" tIns="45720" rIns="91440" bIns="45720" rtlCol="0" anchor="b"/>
-          <a:lstStyle>
-            <a:lvl1pPr algn="r">
-              <a:defRPr sz="1200"/>
-            </a:lvl1pPr>
-          </a:lstStyle>
-          <a:p>
-            <a:fld id="{CE5E9CC1-C706-0F49-92D6-E571CC5EEA8F}" type="slidenum">
-              <a:rPr lang="en-US"/>
-              <a:t>‹#›</a:t>
-            </a:fld>
-            <a:endParaRPr lang="en-US"/>
-          </a:p>
-        </p:txBody>
-      </p:sp>
     </p:spTree>
     <p:extLst>
       <p:ext uri="{BB962C8B-B14F-4D97-AF65-F5344CB8AC3E}">
-        <p14:creationId xmlns:p14="http://schemas.microsoft.com/office/powerpoint/2010/main" val="1024086991"/>
+        <p14:creationId xmlns:p14="http://schemas.microsoft.com/office/powerpoint/2010/main" val="2904116418"/>
       </p:ext>
     </p:extLst>
   </p:cSld>
@@ -519,10 +300,6 @@
           <a:bodyPr/>
           <a:lstStyle/>
           <a:p>
-            <a:r>
-              <a:rPr lang="en-US" dirty="0"/>
-              <a:t/>
-            </a:r>
             <a:endParaRPr lang="en-US" dirty="0"/>
           </a:p>
         </p:txBody>
@@ -607,10 +384,6 @@
           <a:bodyPr/>
           <a:lstStyle/>
           <a:p>
-            <a:r>
-              <a:rPr lang="en-US" dirty="0"/>
-              <a:t/>
-            </a:r>
             <a:endParaRPr lang="en-US" dirty="0"/>
           </a:p>
         </p:txBody>
@@ -695,10 +468,6 @@
           <a:bodyPr/>
           <a:lstStyle/>
           <a:p>
-            <a:r>
-              <a:rPr lang="en-US" dirty="0"/>
-              <a:t/>
-            </a:r>
             <a:endParaRPr lang="en-US" dirty="0"/>
           </a:p>
         </p:txBody>
@@ -783,10 +552,6 @@
           <a:bodyPr/>
           <a:lstStyle/>
           <a:p>
-            <a:r>
-              <a:rPr lang="en-US" dirty="0"/>
-              <a:t/>
-            </a:r>
             <a:endParaRPr lang="en-US" dirty="0"/>
           </a:p>
         </p:txBody>
@@ -871,10 +636,6 @@
           <a:bodyPr/>
           <a:lstStyle/>
           <a:p>
-            <a:r>
-              <a:rPr lang="en-US" dirty="0"/>
-              <a:t/>
-            </a:r>
             <a:endParaRPr lang="en-US" dirty="0"/>
           </a:p>
         </p:txBody>
@@ -959,10 +720,6 @@
           <a:bodyPr/>
           <a:lstStyle/>
           <a:p>
-            <a:r>
-              <a:rPr lang="en-US" dirty="0"/>
-              <a:t/>
-            </a:r>
             <a:endParaRPr lang="en-US" dirty="0"/>
           </a:p>
         </p:txBody>
@@ -1041,6 +798,7 @@
         <a:solidFill>
           <a:srgbClr val="000000"/>
         </a:solidFill>
+        <a:effectLst/>
       </p:bgPr>
     </p:bg>
     <p:spTree>
@@ -1100,7 +858,7 @@
       <p:pic>
         <p:nvPicPr>
           <p:cNvPr id="4" name="Image 0" descr="preencoded.png">
-            <a:hlinkClick r:id="rId2" tooltip=""/>
+            <a:hlinkClick r:id="rId2"/>
           </p:cNvPr>
           <p:cNvPicPr>
             <a:picLocks noChangeAspect="1"/>
@@ -1108,7 +866,7 @@
           <p:nvPr/>
         </p:nvPicPr>
         <p:blipFill>
-          <a:blip r:embed="rId1"/>
+          <a:blip r:embed="rId3"/>
           <a:stretch>
             <a:fillRect/>
           </a:stretch>
@@ -1134,6 +892,11 @@
 <file path=ppt/slideMasters/slideMaster1.xml><?xml version="1.0" encoding="utf-8"?>
 <p:sldMaster xmlns:a="http://schemas.openxmlformats.org/drawingml/2006/main" xmlns:r="http://schemas.openxmlformats.org/officeDocument/2006/relationships" xmlns:p="http://schemas.openxmlformats.org/presentationml/2006/main">
   <p:cSld>
+    <p:bg>
+      <p:bgRef idx="1001">
+        <a:schemeClr val="bg1"/>
+      </p:bgRef>
+    </p:bg>
     <p:spTree>
       <p:nvGrpSpPr>
         <p:cNvPr id="1" name=""/>
@@ -1428,14 +1191,14 @@
       </p:grpSpPr>
       <p:pic>
         <p:nvPicPr>
-          <p:cNvPr id="2" name="Image 0" descr="">    </p:cNvPr>
+          <p:cNvPr id="2" name="Image 0"/>
           <p:cNvPicPr>
             <a:picLocks noChangeAspect="1"/>
           </p:cNvPicPr>
           <p:nvPr/>
         </p:nvPicPr>
         <p:blipFill>
-          <a:blip r:embed="rId1"/>
+          <a:blip r:embed="rId3"/>
           <a:stretch>
             <a:fillRect/>
           </a:stretch>
@@ -1555,7 +1318,7 @@
           <a:bodyPr wrap="none" lIns="0" tIns="0" rIns="0" bIns="0" rtlCol="0" anchor="t"/>
           <a:lstStyle/>
           <a:p>
-            <a:pPr algn="l" indent="0" marL="0">
+            <a:pPr marL="0" indent="0" algn="l">
               <a:lnSpc>
                 <a:spcPct val="104000"/>
               </a:lnSpc>
@@ -1599,7 +1362,7 @@
           </a:bodyPr>
           <a:lstStyle/>
           <a:p>
-            <a:pPr algn="l" indent="0" marL="0">
+            <a:pPr marL="0" indent="0" algn="l">
               <a:lnSpc>
                 <a:spcPct val="104000"/>
               </a:lnSpc>
@@ -1643,7 +1406,7 @@
           </a:bodyPr>
           <a:lstStyle/>
           <a:p>
-            <a:pPr algn="l" indent="0" marL="0">
+            <a:pPr marL="0" indent="0" algn="l">
               <a:lnSpc>
                 <a:spcPct val="120000"/>
               </a:lnSpc>
@@ -1660,14 +1423,148 @@
               </a:rPr>
               <a:t> Transforming everyday smartphones into passive, autonomous civic watchdogs that collect tamper‑resistant photographic proof and contextual telemetry. </a:t>
             </a:r>
-            <a:pPr algn="l" indent="0" marL="0">
+            <a:r>
+              <a:rPr lang="en-US" sz="1150" b="1" dirty="0">
+                <a:solidFill>
+                  <a:srgbClr val="1E3063"/>
+                </a:solidFill>
+                <a:latin typeface="Instrument Sans Bold" pitchFamily="34" charset="0"/>
+                <a:ea typeface="Instrument Sans Bold" pitchFamily="34" charset="-122"/>
+                <a:cs typeface="Instrument Sans Bold" pitchFamily="34" charset="-120"/>
+              </a:rPr>
+              <a:t>Core philosophy:</a:t>
+            </a:r>
+            <a:r>
+              <a:rPr lang="en-US" sz="1150" dirty="0">
+                <a:solidFill>
+                  <a:srgbClr val="1E3063"/>
+                </a:solidFill>
+                <a:latin typeface="Instrument Sans Medium" pitchFamily="34" charset="0"/>
+                <a:ea typeface="Instrument Sans Medium" pitchFamily="34" charset="-122"/>
+                <a:cs typeface="Instrument Sans Medium" pitchFamily="34" charset="-120"/>
+              </a:rPr>
+              <a:t> "Your City. Your Proof. Your Voice." </a:t>
+            </a:r>
+            <a:endParaRPr lang="en-US" sz="1150" dirty="0"/>
+          </a:p>
+        </p:txBody>
+      </p:sp>
+      <p:sp>
+        <p:nvSpPr>
+          <p:cNvPr id="6" name="Shape 3"/>
+          <p:cNvSpPr/>
+          <p:nvPr/>
+        </p:nvSpPr>
+        <p:spPr>
+          <a:xfrm>
+            <a:off x="661475" y="3196233"/>
+            <a:ext cx="3087908" cy="1046559"/>
+          </a:xfrm>
+          <a:prstGeom prst="roundRect">
+            <a:avLst>
+              <a:gd name="adj" fmla="val 13004"/>
+            </a:avLst>
+          </a:prstGeom>
+          <a:solidFill>
+            <a:srgbClr val="CEE6FD"/>
+          </a:solidFill>
+          <a:ln/>
+        </p:spPr>
+      </p:sp>
+      <p:sp>
+        <p:nvSpPr>
+          <p:cNvPr id="7" name="Text 4"/>
+          <p:cNvSpPr/>
+          <p:nvPr/>
+        </p:nvSpPr>
+        <p:spPr>
+          <a:xfrm>
+            <a:off x="812680" y="3347442"/>
+            <a:ext cx="2785497" cy="236240"/>
+          </a:xfrm>
+          <a:prstGeom prst="rect">
+            <a:avLst/>
+          </a:prstGeom>
+          <a:noFill/>
+          <a:ln/>
+        </p:spPr>
+        <p:txBody>
+          <a:bodyPr wrap="none" lIns="0" tIns="0" rIns="0" bIns="0" rtlCol="0" anchor="t"/>
+          <a:lstStyle/>
+          <a:p>
+            <a:pPr>
+              <a:lnSpc>
+                <a:spcPct val="104000"/>
+              </a:lnSpc>
+            </a:pPr>
+            <a:r>
+              <a:rPr lang="en-US" dirty="0">
+                <a:solidFill>
+                  <a:srgbClr val="1E3063"/>
+                </a:solidFill>
+                <a:latin typeface="Instrument Sans SemiBold" pitchFamily="34" charset="0"/>
+                <a:ea typeface="Instrument Sans SemiBold" pitchFamily="34" charset="-122"/>
+                <a:cs typeface="Instrument Sans SemiBold" pitchFamily="34" charset="-120"/>
+              </a:rPr>
+              <a:t>Team </a:t>
+            </a:r>
+            <a:r>
+              <a:rPr lang="en-US" sz="2000" dirty="0" err="1">
+                <a:solidFill>
+                  <a:srgbClr val="1E3063"/>
+                </a:solidFill>
+                <a:latin typeface="Instrument Sans Medium" pitchFamily="34" charset="0"/>
+                <a:ea typeface="Instrument Sans Medium" pitchFamily="34" charset="-122"/>
+                <a:cs typeface="Instrument Sans Medium" pitchFamily="34" charset="-120"/>
+              </a:rPr>
+              <a:t>Nivara</a:t>
+            </a:r>
+            <a:endParaRPr lang="en-US" dirty="0"/>
+          </a:p>
+        </p:txBody>
+      </p:sp>
+      <p:sp>
+        <p:nvSpPr>
+          <p:cNvPr id="8" name="Text 5"/>
+          <p:cNvSpPr/>
+          <p:nvPr/>
+        </p:nvSpPr>
+        <p:spPr>
+          <a:xfrm>
+            <a:off x="812680" y="3796171"/>
+            <a:ext cx="2785497" cy="435372"/>
+          </a:xfrm>
+          <a:prstGeom prst="rect">
+            <a:avLst/>
+          </a:prstGeom>
+          <a:noFill/>
+          <a:ln/>
+        </p:spPr>
+        <p:txBody>
+          <a:bodyPr wrap="square" lIns="0" tIns="0" rIns="0" bIns="0" rtlCol="0" anchor="t">
+            <a:normAutofit/>
+          </a:bodyPr>
+          <a:lstStyle/>
+          <a:p>
+            <a:pPr marL="0" indent="0" algn="l">
               <a:lnSpc>
                 <a:spcPct val="120000"/>
               </a:lnSpc>
               <a:buNone/>
             </a:pPr>
             <a:r>
-              <a:rPr lang="en-US" sz="1150" b="1" dirty="0">
+              <a:rPr lang="en-US" sz="1400" dirty="0">
+                <a:solidFill>
+                  <a:srgbClr val="1E3063"/>
+                </a:solidFill>
+                <a:latin typeface="Instrument Sans Medium" pitchFamily="34" charset="0"/>
+                <a:ea typeface="Instrument Sans Medium" pitchFamily="34" charset="-122"/>
+                <a:cs typeface="Instrument Sans Medium" pitchFamily="34" charset="-120"/>
+              </a:rPr>
+              <a:t>Developed by </a:t>
+            </a:r>
+            <a:r>
+              <a:rPr lang="en-US" sz="1400" b="1" dirty="0">
                 <a:solidFill>
                   <a:srgbClr val="1E3063"/>
                 </a:solidFill>
@@ -1675,9 +1572,100 @@
                 <a:ea typeface="Instrument Sans Bold" pitchFamily="34" charset="-122"/>
                 <a:cs typeface="Instrument Sans Bold" pitchFamily="34" charset="-120"/>
               </a:rPr>
-              <a:t>Core philosophy:</a:t>
-            </a:r>
-            <a:pPr algn="l" indent="0" marL="0">
+              <a:t>Adithyan H</a:t>
+            </a:r>
+            <a:endParaRPr lang="en-US" sz="1400" dirty="0"/>
+          </a:p>
+        </p:txBody>
+      </p:sp>
+      <p:sp>
+        <p:nvSpPr>
+          <p:cNvPr id="9" name="Shape 6"/>
+          <p:cNvSpPr/>
+          <p:nvPr/>
+        </p:nvSpPr>
+        <p:spPr>
+          <a:xfrm>
+            <a:off x="3870327" y="3196233"/>
+            <a:ext cx="3088007" cy="1046559"/>
+          </a:xfrm>
+          <a:prstGeom prst="roundRect">
+            <a:avLst>
+              <a:gd name="adj" fmla="val 13004"/>
+            </a:avLst>
+          </a:prstGeom>
+          <a:solidFill>
+            <a:srgbClr val="CEE6FD"/>
+          </a:solidFill>
+          <a:ln/>
+        </p:spPr>
+      </p:sp>
+      <p:sp>
+        <p:nvSpPr>
+          <p:cNvPr id="10" name="Text 7"/>
+          <p:cNvSpPr/>
+          <p:nvPr/>
+        </p:nvSpPr>
+        <p:spPr>
+          <a:xfrm>
+            <a:off x="4021533" y="3347442"/>
+            <a:ext cx="2785596" cy="236240"/>
+          </a:xfrm>
+          <a:prstGeom prst="rect">
+            <a:avLst/>
+          </a:prstGeom>
+          <a:noFill/>
+          <a:ln/>
+        </p:spPr>
+        <p:txBody>
+          <a:bodyPr wrap="none" lIns="0" tIns="0" rIns="0" bIns="0" rtlCol="0" anchor="t"/>
+          <a:lstStyle/>
+          <a:p>
+            <a:pPr marL="0" indent="0" algn="l">
+              <a:lnSpc>
+                <a:spcPct val="104000"/>
+              </a:lnSpc>
+              <a:buNone/>
+            </a:pPr>
+            <a:r>
+              <a:rPr lang="en-US" sz="1450" dirty="0">
+                <a:solidFill>
+                  <a:srgbClr val="1E3063"/>
+                </a:solidFill>
+                <a:latin typeface="Instrument Sans SemiBold" pitchFamily="34" charset="0"/>
+                <a:ea typeface="Instrument Sans SemiBold" pitchFamily="34" charset="-122"/>
+                <a:cs typeface="Instrument Sans SemiBold" pitchFamily="34" charset="-120"/>
+              </a:rPr>
+              <a:t>Track</a:t>
+            </a:r>
+            <a:endParaRPr lang="en-US" sz="1450" dirty="0"/>
+          </a:p>
+        </p:txBody>
+      </p:sp>
+      <p:sp>
+        <p:nvSpPr>
+          <p:cNvPr id="11" name="Text 8"/>
+          <p:cNvSpPr/>
+          <p:nvPr/>
+        </p:nvSpPr>
+        <p:spPr>
+          <a:xfrm>
+            <a:off x="4021533" y="3656211"/>
+            <a:ext cx="2785596" cy="435372"/>
+          </a:xfrm>
+          <a:prstGeom prst="rect">
+            <a:avLst/>
+          </a:prstGeom>
+          <a:noFill/>
+          <a:ln/>
+        </p:spPr>
+        <p:txBody>
+          <a:bodyPr wrap="square" lIns="0" tIns="0" rIns="0" bIns="0" rtlCol="0" anchor="t">
+            <a:normAutofit/>
+          </a:bodyPr>
+          <a:lstStyle/>
+          <a:p>
+            <a:pPr marL="0" indent="0" algn="l">
               <a:lnSpc>
                 <a:spcPct val="120000"/>
               </a:lnSpc>
@@ -1692,7 +1680,18 @@
                 <a:ea typeface="Instrument Sans Medium" pitchFamily="34" charset="-122"/>
                 <a:cs typeface="Instrument Sans Medium" pitchFamily="34" charset="-120"/>
               </a:rPr>
-              <a:t> "Your City. Your Proof. Your Voice." </a:t>
+              <a:t>AppSprint 2026 · CivicTech Track · Production Release </a:t>
+            </a:r>
+            <a:r>
+              <a:rPr lang="en-US" sz="1150" b="1" dirty="0">
+                <a:solidFill>
+                  <a:srgbClr val="1E3063"/>
+                </a:solidFill>
+                <a:latin typeface="Instrument Sans Bold" pitchFamily="34" charset="0"/>
+                <a:ea typeface="Instrument Sans Bold" pitchFamily="34" charset="-122"/>
+                <a:cs typeface="Instrument Sans Bold" pitchFamily="34" charset="-120"/>
+              </a:rPr>
+              <a:t>v1.0.65</a:t>
             </a:r>
             <a:endParaRPr lang="en-US" sz="1150" dirty="0"/>
           </a:p>
@@ -1700,14 +1699,14 @@
       </p:sp>
       <p:sp>
         <p:nvSpPr>
-          <p:cNvPr id="6" name="Shape 3"/>
-          <p:cNvSpPr/>
-          <p:nvPr/>
-        </p:nvSpPr>
-        <p:spPr>
-          <a:xfrm>
-            <a:off x="661475" y="3196233"/>
-            <a:ext cx="3087908" cy="1046559"/>
+          <p:cNvPr id="12" name="Shape 9"/>
+          <p:cNvSpPr/>
+          <p:nvPr/>
+        </p:nvSpPr>
+        <p:spPr>
+          <a:xfrm>
+            <a:off x="661475" y="4363740"/>
+            <a:ext cx="6296860" cy="1046559"/>
           </a:xfrm>
           <a:prstGeom prst="roundRect">
             <a:avLst>
@@ -1722,14 +1721,14 @@
       </p:sp>
       <p:sp>
         <p:nvSpPr>
-          <p:cNvPr id="7" name="Text 4"/>
-          <p:cNvSpPr/>
-          <p:nvPr/>
-        </p:nvSpPr>
-        <p:spPr>
-          <a:xfrm>
-            <a:off x="812680" y="3347442"/>
-            <a:ext cx="2785497" cy="236240"/>
+          <p:cNvPr id="13" name="Text 10"/>
+          <p:cNvSpPr/>
+          <p:nvPr/>
+        </p:nvSpPr>
+        <p:spPr>
+          <a:xfrm>
+            <a:off x="812680" y="4514949"/>
+            <a:ext cx="5994448" cy="236240"/>
           </a:xfrm>
           <a:prstGeom prst="rect">
             <a:avLst/>
@@ -1741,7 +1740,7 @@
           <a:bodyPr wrap="none" lIns="0" tIns="0" rIns="0" bIns="0" rtlCol="0" anchor="t"/>
           <a:lstStyle/>
           <a:p>
-            <a:pPr algn="l" indent="0" marL="0">
+            <a:pPr marL="0" indent="0" algn="l">
               <a:lnSpc>
                 <a:spcPct val="104000"/>
               </a:lnSpc>
@@ -1756,7 +1755,7 @@
                 <a:ea typeface="Instrument Sans SemiBold" pitchFamily="34" charset="-122"/>
                 <a:cs typeface="Instrument Sans SemiBold" pitchFamily="34" charset="-120"/>
               </a:rPr>
-              <a:t>Team</a:t>
+              <a:t>Core Tech</a:t>
             </a:r>
             <a:endParaRPr lang="en-US" sz="1450" dirty="0"/>
           </a:p>
@@ -1764,14 +1763,14 @@
       </p:sp>
       <p:sp>
         <p:nvSpPr>
-          <p:cNvPr id="8" name="Text 5"/>
-          <p:cNvSpPr/>
-          <p:nvPr/>
-        </p:nvSpPr>
-        <p:spPr>
-          <a:xfrm>
-            <a:off x="812680" y="3656211"/>
-            <a:ext cx="2785497" cy="435372"/>
+          <p:cNvPr id="14" name="Text 11"/>
+          <p:cNvSpPr/>
+          <p:nvPr/>
+        </p:nvSpPr>
+        <p:spPr>
+          <a:xfrm>
+            <a:off x="812680" y="4823718"/>
+            <a:ext cx="5994448" cy="435372"/>
           </a:xfrm>
           <a:prstGeom prst="rect">
             <a:avLst/>
@@ -1785,7 +1784,7 @@
           </a:bodyPr>
           <a:lstStyle/>
           <a:p>
-            <a:pPr algn="l" indent="0" marL="0">
+            <a:pPr marL="0" indent="0" algn="l">
               <a:lnSpc>
                 <a:spcPct val="120000"/>
               </a:lnSpc>
@@ -1800,123 +1799,61 @@
                 <a:ea typeface="Instrument Sans Medium" pitchFamily="34" charset="-122"/>
                 <a:cs typeface="Instrument Sans Medium" pitchFamily="34" charset="-120"/>
               </a:rPr>
-              <a:t>Team Nivara — Developed by </a:t>
-            </a:r>
-            <a:pPr algn="l" indent="0" marL="0">
+              <a:t>Flutter 3.x	 · </a:t>
+            </a:r>
+            <a:r>
+              <a:rPr lang="en-US" sz="1150" dirty="0" err="1">
+                <a:solidFill>
+                  <a:srgbClr val="1E3063"/>
+                </a:solidFill>
+                <a:latin typeface="Instrument Sans Medium" pitchFamily="34" charset="0"/>
+                <a:ea typeface="Instrument Sans Medium" pitchFamily="34" charset="-122"/>
+                <a:cs typeface="Instrument Sans Medium" pitchFamily="34" charset="-120"/>
+              </a:rPr>
+              <a:t>Supabase</a:t>
+            </a:r>
+            <a:r>
+              <a:rPr lang="en-US" sz="1150" dirty="0">
+                <a:solidFill>
+                  <a:srgbClr val="1E3063"/>
+                </a:solidFill>
+                <a:latin typeface="Instrument Sans Medium" pitchFamily="34" charset="0"/>
+                <a:ea typeface="Instrument Sans Medium" pitchFamily="34" charset="-122"/>
+                <a:cs typeface="Instrument Sans Medium" pitchFamily="34" charset="-120"/>
+              </a:rPr>
+              <a:t> PostgreSQL 15 + </a:t>
+            </a:r>
+            <a:r>
+              <a:rPr lang="en-US" sz="1150" dirty="0" err="1">
+                <a:solidFill>
+                  <a:srgbClr val="1E3063"/>
+                </a:solidFill>
+                <a:latin typeface="Instrument Sans Medium" pitchFamily="34" charset="0"/>
+                <a:ea typeface="Instrument Sans Medium" pitchFamily="34" charset="-122"/>
+                <a:cs typeface="Instrument Sans Medium" pitchFamily="34" charset="-120"/>
+              </a:rPr>
+              <a:t>PostGIS</a:t>
+            </a:r>
+            <a:r>
+              <a:rPr lang="en-US" sz="1150" dirty="0">
+                <a:solidFill>
+                  <a:srgbClr val="1E3063"/>
+                </a:solidFill>
+                <a:latin typeface="Instrument Sans Medium" pitchFamily="34" charset="0"/>
+                <a:ea typeface="Instrument Sans Medium" pitchFamily="34" charset="-122"/>
+                <a:cs typeface="Instrument Sans Medium" pitchFamily="34" charset="-120"/>
+              </a:rPr>
+              <a:t> </a:t>
+            </a:r>
+          </a:p>
+          <a:p>
+            <a:pPr marL="0" indent="0" algn="l">
               <a:lnSpc>
                 <a:spcPct val="120000"/>
               </a:lnSpc>
               <a:buNone/>
             </a:pPr>
             <a:r>
-              <a:rPr lang="en-US" sz="1150" b="1" dirty="0">
-                <a:solidFill>
-                  <a:srgbClr val="1E3063"/>
-                </a:solidFill>
-                <a:latin typeface="Instrument Sans Bold" pitchFamily="34" charset="0"/>
-                <a:ea typeface="Instrument Sans Bold" pitchFamily="34" charset="-122"/>
-                <a:cs typeface="Instrument Sans Bold" pitchFamily="34" charset="-120"/>
-              </a:rPr>
-              <a:t>Adithyan H</a:t>
-            </a:r>
-            <a:endParaRPr lang="en-US" sz="1150" dirty="0"/>
-          </a:p>
-        </p:txBody>
-      </p:sp>
-      <p:sp>
-        <p:nvSpPr>
-          <p:cNvPr id="9" name="Shape 6"/>
-          <p:cNvSpPr/>
-          <p:nvPr/>
-        </p:nvSpPr>
-        <p:spPr>
-          <a:xfrm>
-            <a:off x="3870327" y="3196233"/>
-            <a:ext cx="3088007" cy="1046559"/>
-          </a:xfrm>
-          <a:prstGeom prst="roundRect">
-            <a:avLst>
-              <a:gd name="adj" fmla="val 13004"/>
-            </a:avLst>
-          </a:prstGeom>
-          <a:solidFill>
-            <a:srgbClr val="CEE6FD"/>
-          </a:solidFill>
-          <a:ln/>
-        </p:spPr>
-      </p:sp>
-      <p:sp>
-        <p:nvSpPr>
-          <p:cNvPr id="10" name="Text 7"/>
-          <p:cNvSpPr/>
-          <p:nvPr/>
-        </p:nvSpPr>
-        <p:spPr>
-          <a:xfrm>
-            <a:off x="4021533" y="3347442"/>
-            <a:ext cx="2785596" cy="236240"/>
-          </a:xfrm>
-          <a:prstGeom prst="rect">
-            <a:avLst/>
-          </a:prstGeom>
-          <a:noFill/>
-          <a:ln/>
-        </p:spPr>
-        <p:txBody>
-          <a:bodyPr wrap="none" lIns="0" tIns="0" rIns="0" bIns="0" rtlCol="0" anchor="t"/>
-          <a:lstStyle/>
-          <a:p>
-            <a:pPr algn="l" indent="0" marL="0">
-              <a:lnSpc>
-                <a:spcPct val="104000"/>
-              </a:lnSpc>
-              <a:buNone/>
-            </a:pPr>
-            <a:r>
-              <a:rPr lang="en-US" sz="1450" dirty="0">
-                <a:solidFill>
-                  <a:srgbClr val="1E3063"/>
-                </a:solidFill>
-                <a:latin typeface="Instrument Sans SemiBold" pitchFamily="34" charset="0"/>
-                <a:ea typeface="Instrument Sans SemiBold" pitchFamily="34" charset="-122"/>
-                <a:cs typeface="Instrument Sans SemiBold" pitchFamily="34" charset="-120"/>
-              </a:rPr>
-              <a:t>Track</a:t>
-            </a:r>
-            <a:endParaRPr lang="en-US" sz="1450" dirty="0"/>
-          </a:p>
-        </p:txBody>
-      </p:sp>
-      <p:sp>
-        <p:nvSpPr>
-          <p:cNvPr id="11" name="Text 8"/>
-          <p:cNvSpPr/>
-          <p:nvPr/>
-        </p:nvSpPr>
-        <p:spPr>
-          <a:xfrm>
-            <a:off x="4021533" y="3656211"/>
-            <a:ext cx="2785596" cy="435372"/>
-          </a:xfrm>
-          <a:prstGeom prst="rect">
-            <a:avLst/>
-          </a:prstGeom>
-          <a:noFill/>
-          <a:ln/>
-        </p:spPr>
-        <p:txBody>
-          <a:bodyPr wrap="square" lIns="0" tIns="0" rIns="0" bIns="0" rtlCol="0" anchor="t">
-            <a:normAutofit/>
-          </a:bodyPr>
-          <a:lstStyle/>
-          <a:p>
-            <a:pPr algn="l" indent="0" marL="0">
-              <a:lnSpc>
-                <a:spcPct val="120000"/>
-              </a:lnSpc>
-              <a:buNone/>
-            </a:pPr>
-            <a:r>
               <a:rPr lang="en-US" sz="1150" dirty="0">
                 <a:solidFill>
                   <a:srgbClr val="1E3063"/>
@@ -1925,132 +1862,7 @@
                 <a:ea typeface="Instrument Sans Medium" pitchFamily="34" charset="-122"/>
                 <a:cs typeface="Instrument Sans Medium" pitchFamily="34" charset="-120"/>
               </a:rPr>
-              <a:t>AppSprint 2026 · CivicTech Track · Production Release </a:t>
-            </a:r>
-            <a:pPr algn="l" indent="0" marL="0">
-              <a:lnSpc>
-                <a:spcPct val="120000"/>
-              </a:lnSpc>
-              <a:buNone/>
-            </a:pPr>
-            <a:r>
-              <a:rPr lang="en-US" sz="1150" b="1" dirty="0">
-                <a:solidFill>
-                  <a:srgbClr val="1E3063"/>
-                </a:solidFill>
-                <a:latin typeface="Instrument Sans Bold" pitchFamily="34" charset="0"/>
-                <a:ea typeface="Instrument Sans Bold" pitchFamily="34" charset="-122"/>
-                <a:cs typeface="Instrument Sans Bold" pitchFamily="34" charset="-120"/>
-              </a:rPr>
-              <a:t>v1.0.65</a:t>
-            </a:r>
-            <a:endParaRPr lang="en-US" sz="1150" dirty="0"/>
-          </a:p>
-        </p:txBody>
-      </p:sp>
-      <p:sp>
-        <p:nvSpPr>
-          <p:cNvPr id="12" name="Shape 9"/>
-          <p:cNvSpPr/>
-          <p:nvPr/>
-        </p:nvSpPr>
-        <p:spPr>
-          <a:xfrm>
-            <a:off x="661475" y="4363740"/>
-            <a:ext cx="6296860" cy="1046559"/>
-          </a:xfrm>
-          <a:prstGeom prst="roundRect">
-            <a:avLst>
-              <a:gd name="adj" fmla="val 13004"/>
-            </a:avLst>
-          </a:prstGeom>
-          <a:solidFill>
-            <a:srgbClr val="CEE6FD"/>
-          </a:solidFill>
-          <a:ln/>
-        </p:spPr>
-      </p:sp>
-      <p:sp>
-        <p:nvSpPr>
-          <p:cNvPr id="13" name="Text 10"/>
-          <p:cNvSpPr/>
-          <p:nvPr/>
-        </p:nvSpPr>
-        <p:spPr>
-          <a:xfrm>
-            <a:off x="812680" y="4514949"/>
-            <a:ext cx="5994448" cy="236240"/>
-          </a:xfrm>
-          <a:prstGeom prst="rect">
-            <a:avLst/>
-          </a:prstGeom>
-          <a:noFill/>
-          <a:ln/>
-        </p:spPr>
-        <p:txBody>
-          <a:bodyPr wrap="none" lIns="0" tIns="0" rIns="0" bIns="0" rtlCol="0" anchor="t"/>
-          <a:lstStyle/>
-          <a:p>
-            <a:pPr algn="l" indent="0" marL="0">
-              <a:lnSpc>
-                <a:spcPct val="104000"/>
-              </a:lnSpc>
-              <a:buNone/>
-            </a:pPr>
-            <a:r>
-              <a:rPr lang="en-US" sz="1450" dirty="0">
-                <a:solidFill>
-                  <a:srgbClr val="1E3063"/>
-                </a:solidFill>
-                <a:latin typeface="Instrument Sans SemiBold" pitchFamily="34" charset="0"/>
-                <a:ea typeface="Instrument Sans SemiBold" pitchFamily="34" charset="-122"/>
-                <a:cs typeface="Instrument Sans SemiBold" pitchFamily="34" charset="-120"/>
-              </a:rPr>
-              <a:t>Core Tech</a:t>
-            </a:r>
-            <a:endParaRPr lang="en-US" sz="1450" dirty="0"/>
-          </a:p>
-        </p:txBody>
-      </p:sp>
-      <p:sp>
-        <p:nvSpPr>
-          <p:cNvPr id="14" name="Text 11"/>
-          <p:cNvSpPr/>
-          <p:nvPr/>
-        </p:nvSpPr>
-        <p:spPr>
-          <a:xfrm>
-            <a:off x="812680" y="4823718"/>
-            <a:ext cx="5994448" cy="435372"/>
-          </a:xfrm>
-          <a:prstGeom prst="rect">
-            <a:avLst/>
-          </a:prstGeom>
-          <a:noFill/>
-          <a:ln/>
-        </p:spPr>
-        <p:txBody>
-          <a:bodyPr wrap="square" lIns="0" tIns="0" rIns="0" bIns="0" rtlCol="0" anchor="t">
-            <a:normAutofit/>
-          </a:bodyPr>
-          <a:lstStyle/>
-          <a:p>
-            <a:pPr algn="l" indent="0" marL="0">
-              <a:lnSpc>
-                <a:spcPct val="120000"/>
-              </a:lnSpc>
-              <a:buNone/>
-            </a:pPr>
-            <a:r>
-              <a:rPr lang="en-US" sz="1150" dirty="0">
-                <a:solidFill>
-                  <a:srgbClr val="1E3063"/>
-                </a:solidFill>
-                <a:latin typeface="Instrument Sans Medium" pitchFamily="34" charset="0"/>
-                <a:ea typeface="Instrument Sans Medium" pitchFamily="34" charset="-122"/>
-                <a:cs typeface="Instrument Sans Medium" pitchFamily="34" charset="-120"/>
-              </a:rPr>
-              <a:t>Flutter 3.x · Supabase PostgreSQL 15 + PostGIS · NVIDIA NIM Llama‑3.2 Vision AI · Ola Maps Vector Engine</a:t>
+              <a:t>· NVIDIA NIM Llama‑3.2 Vision AI 	· Ola Maps Vector Engine</a:t>
             </a:r>
             <a:endParaRPr lang="en-US" sz="1150" dirty="0"/>
           </a:p>
@@ -2080,14 +1892,14 @@
       </p:sp>
       <p:pic>
         <p:nvPicPr>
-          <p:cNvPr id="16" name="Image 1" descr="preencoded.png">    </p:cNvPr>
+          <p:cNvPr id="16" name="Image 1" descr="preencoded.png"/>
           <p:cNvPicPr>
             <a:picLocks noChangeAspect="1"/>
           </p:cNvPicPr>
           <p:nvPr/>
         </p:nvPicPr>
         <p:blipFill>
-          <a:blip r:embed="rId2"/>
+          <a:blip r:embed="rId4"/>
           <a:stretch>
             <a:fillRect/>
           </a:stretch>
@@ -2125,7 +1937,7 @@
           </a:bodyPr>
           <a:lstStyle/>
           <a:p>
-            <a:pPr algn="l" indent="0" marL="0">
+            <a:pPr marL="0" indent="0" algn="l">
               <a:lnSpc>
                 <a:spcPct val="120000"/>
               </a:lnSpc>
@@ -2192,7 +2004,7 @@
           <a:bodyPr wrap="none" lIns="0" tIns="0" rIns="0" bIns="0" rtlCol="0" anchor="t"/>
           <a:lstStyle/>
           <a:p>
-            <a:pPr algn="l" indent="0" marL="0">
+            <a:pPr marL="0" indent="0" algn="l">
               <a:lnSpc>
                 <a:spcPct val="104000"/>
               </a:lnSpc>
@@ -2236,7 +2048,7 @@
           </a:bodyPr>
           <a:lstStyle/>
           <a:p>
-            <a:pPr algn="l" indent="0" marL="0">
+            <a:pPr marL="0" indent="0" algn="l">
               <a:lnSpc>
                 <a:spcPct val="117000"/>
               </a:lnSpc>
@@ -2259,7 +2071,7 @@
             <a:endParaRPr lang="en-US" sz="1100" dirty="0"/>
           </a:p>
           <a:p>
-            <a:pPr algn="l" indent="0" marL="0">
+            <a:pPr marL="0" indent="0" algn="l">
               <a:lnSpc>
                 <a:spcPct val="117000"/>
               </a:lnSpc>
@@ -2279,7 +2091,111 @@
               </a:rPr>
               <a:t>Feature highlight:</a:t>
             </a:r>
-            <a:pPr algn="l" indent="0" marL="0">
+            <a:r>
+              <a:rPr lang="en-US" sz="1100" dirty="0">
+                <a:solidFill>
+                  <a:srgbClr val="1E3063"/>
+                </a:solidFill>
+                <a:latin typeface="Instrument Sans Medium" pitchFamily="34" charset="0"/>
+                <a:ea typeface="Instrument Sans Medium" pitchFamily="34" charset="-122"/>
+                <a:cs typeface="Instrument Sans Medium" pitchFamily="34" charset="-120"/>
+              </a:rPr>
+              <a:t> "Zero Buffering Deadlocks · Sub‑2s Spatial Response · Hyperlocal Citizen Collaboration"</a:t>
+            </a:r>
+            <a:endParaRPr lang="en-US" sz="1100" dirty="0"/>
+          </a:p>
+        </p:txBody>
+      </p:sp>
+      <p:pic>
+        <p:nvPicPr>
+          <p:cNvPr id="4" name="Image 0" descr="preencoded.png"/>
+          <p:cNvPicPr>
+            <a:picLocks noChangeAspect="1"/>
+          </p:cNvPicPr>
+          <p:nvPr/>
+        </p:nvPicPr>
+        <p:blipFill>
+          <a:blip r:embed="rId3"/>
+          <a:stretch>
+            <a:fillRect/>
+          </a:stretch>
+        </p:blipFill>
+        <p:spPr>
+          <a:xfrm>
+            <a:off x="6442112" y="705445"/>
+            <a:ext cx="4366508" cy="2474416"/>
+          </a:xfrm>
+          <a:prstGeom prst="rect">
+            <a:avLst/>
+          </a:prstGeom>
+        </p:spPr>
+      </p:pic>
+      <p:sp>
+        <p:nvSpPr>
+          <p:cNvPr id="5" name="Text 2"/>
+          <p:cNvSpPr/>
+          <p:nvPr/>
+        </p:nvSpPr>
+        <p:spPr>
+          <a:xfrm>
+            <a:off x="5714361" y="3299420"/>
+            <a:ext cx="5822110" cy="221456"/>
+          </a:xfrm>
+          <a:prstGeom prst="rect">
+            <a:avLst/>
+          </a:prstGeom>
+          <a:noFill/>
+          <a:ln/>
+        </p:spPr>
+        <p:txBody>
+          <a:bodyPr wrap="none" lIns="0" tIns="0" rIns="0" bIns="0" rtlCol="0" anchor="t"/>
+          <a:lstStyle/>
+          <a:p>
+            <a:pPr marL="0" indent="0" algn="l">
+              <a:lnSpc>
+                <a:spcPct val="104000"/>
+              </a:lnSpc>
+              <a:buNone/>
+            </a:pPr>
+            <a:r>
+              <a:rPr lang="en-US" sz="1350" dirty="0">
+                <a:solidFill>
+                  <a:srgbClr val="091C53"/>
+                </a:solidFill>
+                <a:latin typeface="Instrument Sans SemiBold" pitchFamily="34" charset="0"/>
+                <a:ea typeface="Instrument Sans SemiBold" pitchFamily="34" charset="-122"/>
+                <a:cs typeface="Instrument Sans SemiBold" pitchFamily="34" charset="-120"/>
+              </a:rPr>
+              <a:t>Ola Maps Dark Vector Engine</a:t>
+            </a:r>
+            <a:endParaRPr lang="en-US" sz="1350" dirty="0"/>
+          </a:p>
+        </p:txBody>
+      </p:sp>
+      <p:sp>
+        <p:nvSpPr>
+          <p:cNvPr id="6" name="Text 3"/>
+          <p:cNvSpPr/>
+          <p:nvPr/>
+        </p:nvSpPr>
+        <p:spPr>
+          <a:xfrm>
+            <a:off x="5714361" y="3627140"/>
+            <a:ext cx="5822110" cy="595313"/>
+          </a:xfrm>
+          <a:prstGeom prst="rect">
+            <a:avLst/>
+          </a:prstGeom>
+          <a:noFill/>
+          <a:ln/>
+        </p:spPr>
+        <p:txBody>
+          <a:bodyPr wrap="square" lIns="0" tIns="0" rIns="0" bIns="0" rtlCol="0" anchor="t">
+            <a:normAutofit/>
+          </a:bodyPr>
+          <a:lstStyle/>
+          <a:p>
+            <a:pPr marL="0" indent="0" algn="l">
               <a:lnSpc>
                 <a:spcPct val="117000"/>
               </a:lnSpc>
@@ -2294,45 +2210,21 @@
                 <a:ea typeface="Instrument Sans Medium" pitchFamily="34" charset="-122"/>
                 <a:cs typeface="Instrument Sans Medium" pitchFamily="34" charset="-120"/>
               </a:rPr>
-              <a:t> "Zero Buffering Deadlocks · Sub‑2s Spatial Response · Hyperlocal Citizen Collaboration"</a:t>
+              <a:t>       High‑performance vector tiles, spatial clustering, custom category pins. Proximity discovery for hospitals, police, fire, public toilets, clean water, and transit. One‑tap SOS beacon with turn‑by‑turn routing to nearest help.     </a:t>
             </a:r>
             <a:endParaRPr lang="en-US" sz="1100" dirty="0"/>
           </a:p>
         </p:txBody>
       </p:sp>
-      <p:pic>
-        <p:nvPicPr>
-          <p:cNvPr id="4" name="Image 0" descr="preencoded.png">    </p:cNvPr>
-          <p:cNvPicPr>
-            <a:picLocks noChangeAspect="1"/>
-          </p:cNvPicPr>
-          <p:nvPr/>
-        </p:nvPicPr>
-        <p:blipFill>
-          <a:blip r:embed="rId1"/>
-          <a:stretch>
-            <a:fillRect/>
-          </a:stretch>
-        </p:blipFill>
-        <p:spPr>
-          <a:xfrm>
-            <a:off x="6442112" y="705445"/>
-            <a:ext cx="4366508" cy="2474416"/>
-          </a:xfrm>
-          <a:prstGeom prst="rect">
-            <a:avLst/>
-          </a:prstGeom>
-        </p:spPr>
-      </p:pic>
-      <p:sp>
-        <p:nvSpPr>
-          <p:cNvPr id="5" name="Text 2"/>
-          <p:cNvSpPr/>
-          <p:nvPr/>
-        </p:nvSpPr>
-        <p:spPr>
-          <a:xfrm>
-            <a:off x="5714361" y="3299420"/>
+      <p:sp>
+        <p:nvSpPr>
+          <p:cNvPr id="7" name="Text 4"/>
+          <p:cNvSpPr/>
+          <p:nvPr/>
+        </p:nvSpPr>
+        <p:spPr>
+          <a:xfrm>
+            <a:off x="5714361" y="4328716"/>
             <a:ext cx="5822110" cy="221456"/>
           </a:xfrm>
           <a:prstGeom prst="rect">
@@ -2345,7 +2237,7 @@
           <a:bodyPr wrap="none" lIns="0" tIns="0" rIns="0" bIns="0" rtlCol="0" anchor="t"/>
           <a:lstStyle/>
           <a:p>
-            <a:pPr algn="l" indent="0" marL="0">
+            <a:pPr marL="0" indent="0" algn="l">
               <a:lnSpc>
                 <a:spcPct val="104000"/>
               </a:lnSpc>
@@ -2360,7 +2252,7 @@
                 <a:ea typeface="Instrument Sans SemiBold" pitchFamily="34" charset="-122"/>
                 <a:cs typeface="Instrument Sans SemiBold" pitchFamily="34" charset="-120"/>
               </a:rPr>
-              <a:t>Ola Maps Dark Vector Engine</a:t>
+              <a:t>Community Board &amp; Verified Polls</a:t>
             </a:r>
             <a:endParaRPr lang="en-US" sz="1350" dirty="0"/>
           </a:p>
@@ -2368,14 +2260,14 @@
       </p:sp>
       <p:sp>
         <p:nvSpPr>
-          <p:cNvPr id="6" name="Text 3"/>
-          <p:cNvSpPr/>
-          <p:nvPr/>
-        </p:nvSpPr>
-        <p:spPr>
-          <a:xfrm>
-            <a:off x="5714361" y="3627140"/>
-            <a:ext cx="5822110" cy="595313"/>
+          <p:cNvPr id="8" name="Text 5"/>
+          <p:cNvSpPr/>
+          <p:nvPr/>
+        </p:nvSpPr>
+        <p:spPr>
+          <a:xfrm>
+            <a:off x="5714361" y="4656435"/>
+            <a:ext cx="5822110" cy="396875"/>
           </a:xfrm>
           <a:prstGeom prst="rect">
             <a:avLst/>
@@ -2389,7 +2281,7 @@
           </a:bodyPr>
           <a:lstStyle/>
           <a:p>
-            <a:pPr algn="l" indent="0" marL="0">
+            <a:pPr marL="0" indent="0" algn="l">
               <a:lnSpc>
                 <a:spcPct val="117000"/>
               </a:lnSpc>
@@ -2404,92 +2296,6 @@
                 <a:ea typeface="Instrument Sans Medium" pitchFamily="34" charset="-122"/>
                 <a:cs typeface="Instrument Sans Medium" pitchFamily="34" charset="-120"/>
               </a:rPr>
-              <a:t>       High‑performance vector tiles, spatial clustering, custom category pins. Proximity discovery for hospitals, police, fire, public toilets, clean water, and transit. One‑tap SOS beacon with turn‑by‑turn routing to nearest help.     </a:t>
-            </a:r>
-            <a:endParaRPr lang="en-US" sz="1100" dirty="0"/>
-          </a:p>
-        </p:txBody>
-      </p:sp>
-      <p:sp>
-        <p:nvSpPr>
-          <p:cNvPr id="7" name="Text 4"/>
-          <p:cNvSpPr/>
-          <p:nvPr/>
-        </p:nvSpPr>
-        <p:spPr>
-          <a:xfrm>
-            <a:off x="5714361" y="4328716"/>
-            <a:ext cx="5822110" cy="221456"/>
-          </a:xfrm>
-          <a:prstGeom prst="rect">
-            <a:avLst/>
-          </a:prstGeom>
-          <a:noFill/>
-          <a:ln/>
-        </p:spPr>
-        <p:txBody>
-          <a:bodyPr wrap="none" lIns="0" tIns="0" rIns="0" bIns="0" rtlCol="0" anchor="t"/>
-          <a:lstStyle/>
-          <a:p>
-            <a:pPr algn="l" indent="0" marL="0">
-              <a:lnSpc>
-                <a:spcPct val="104000"/>
-              </a:lnSpc>
-              <a:buNone/>
-            </a:pPr>
-            <a:r>
-              <a:rPr lang="en-US" sz="1350" dirty="0">
-                <a:solidFill>
-                  <a:srgbClr val="091C53"/>
-                </a:solidFill>
-                <a:latin typeface="Instrument Sans SemiBold" pitchFamily="34" charset="0"/>
-                <a:ea typeface="Instrument Sans SemiBold" pitchFamily="34" charset="-122"/>
-                <a:cs typeface="Instrument Sans SemiBold" pitchFamily="34" charset="-120"/>
-              </a:rPr>
-              <a:t>Community Board &amp; Verified Polls</a:t>
-            </a:r>
-            <a:endParaRPr lang="en-US" sz="1350" dirty="0"/>
-          </a:p>
-        </p:txBody>
-      </p:sp>
-      <p:sp>
-        <p:nvSpPr>
-          <p:cNvPr id="8" name="Text 5"/>
-          <p:cNvSpPr/>
-          <p:nvPr/>
-        </p:nvSpPr>
-        <p:spPr>
-          <a:xfrm>
-            <a:off x="5714361" y="4656435"/>
-            <a:ext cx="5822110" cy="396875"/>
-          </a:xfrm>
-          <a:prstGeom prst="rect">
-            <a:avLst/>
-          </a:prstGeom>
-          <a:noFill/>
-          <a:ln/>
-        </p:spPr>
-        <p:txBody>
-          <a:bodyPr wrap="square" lIns="0" tIns="0" rIns="0" bIns="0" rtlCol="0" anchor="t">
-            <a:normAutofit/>
-          </a:bodyPr>
-          <a:lstStyle/>
-          <a:p>
-            <a:pPr algn="l" indent="0" marL="0">
-              <a:lnSpc>
-                <a:spcPct val="117000"/>
-              </a:lnSpc>
-              <a:buNone/>
-            </a:pPr>
-            <a:r>
-              <a:rPr lang="en-US" sz="1100" dirty="0">
-                <a:solidFill>
-                  <a:srgbClr val="1E3063"/>
-                </a:solidFill>
-                <a:latin typeface="Instrument Sans Medium" pitchFamily="34" charset="0"/>
-                <a:ea typeface="Instrument Sans Medium" pitchFamily="34" charset="-122"/>
-                <a:cs typeface="Instrument Sans Medium" pitchFamily="34" charset="-120"/>
-              </a:rPr>
               <a:t>       Crypto‑bound voting to prevent duplicate votes and a hyperlocal micro‑task board for clean‑ups and volunteer drives.     </a:t>
             </a:r>
             <a:endParaRPr lang="en-US" sz="1100" dirty="0"/>
@@ -2498,17 +2304,17 @@
       </p:sp>
       <p:pic>
         <p:nvPicPr>
-          <p:cNvPr id="9" name="Image 1" descr="preencoded.png">    </p:cNvPr>
+          <p:cNvPr id="9" name="Image 1" descr="preencoded.png"/>
           <p:cNvPicPr>
             <a:picLocks noChangeAspect="1"/>
           </p:cNvPicPr>
           <p:nvPr/>
         </p:nvPicPr>
         <p:blipFill>
-          <a:blip r:embed="rId2">
+          <a:blip>
             <a:extLst>
               <a:ext uri="{96DAC541-7B7A-43D3-8B79-37D633B846F1}">
-                <asvg:svgBlip xmlns:asvg="http://schemas.microsoft.com/office/drawing/2016/SVG/main" r:embed="rId3"/>
+                <asvg:svgBlip xmlns:asvg="http://schemas.microsoft.com/office/drawing/2016/SVG/main" r:embed="rId4"/>
               </a:ext>
             </a:extLst>
           </a:blip>
@@ -2547,7 +2353,7 @@
           <a:bodyPr wrap="none" lIns="0" tIns="0" rIns="0" bIns="0" rtlCol="0" anchor="t"/>
           <a:lstStyle/>
           <a:p>
-            <a:pPr algn="l" indent="0" marL="0">
+            <a:pPr marL="0" indent="0" algn="l">
               <a:lnSpc>
                 <a:spcPct val="104000"/>
               </a:lnSpc>
@@ -2591,7 +2397,7 @@
           </a:bodyPr>
           <a:lstStyle/>
           <a:p>
-            <a:pPr algn="l" indent="0" marL="0">
+            <a:pPr marL="0" indent="0" algn="l">
               <a:lnSpc>
                 <a:spcPct val="117000"/>
               </a:lnSpc>
@@ -2614,17 +2420,17 @@
       </p:sp>
       <p:pic>
         <p:nvPicPr>
-          <p:cNvPr id="12" name="Image 2" descr="preencoded.png">    </p:cNvPr>
+          <p:cNvPr id="12" name="Image 2" descr="preencoded.png"/>
           <p:cNvPicPr>
             <a:picLocks noChangeAspect="1"/>
           </p:cNvPicPr>
           <p:nvPr/>
         </p:nvPicPr>
         <p:blipFill>
-          <a:blip r:embed="rId4">
+          <a:blip>
             <a:extLst>
               <a:ext uri="{96DAC541-7B7A-43D3-8B79-37D633B846F1}">
-                <asvg:svgBlip xmlns:asvg="http://schemas.microsoft.com/office/drawing/2016/SVG/main" r:embed="rId5"/>
+                <asvg:svgBlip xmlns:asvg="http://schemas.microsoft.com/office/drawing/2016/SVG/main" r:embed="rId4"/>
               </a:ext>
             </a:extLst>
           </a:blip>
@@ -2663,7 +2469,7 @@
           <a:bodyPr wrap="none" lIns="0" tIns="0" rIns="0" bIns="0" rtlCol="0" anchor="t"/>
           <a:lstStyle/>
           <a:p>
-            <a:pPr algn="l" indent="0" marL="0">
+            <a:pPr marL="0" indent="0" algn="l">
               <a:lnSpc>
                 <a:spcPct val="104000"/>
               </a:lnSpc>
@@ -2707,7 +2513,7 @@
           </a:bodyPr>
           <a:lstStyle/>
           <a:p>
-            <a:pPr algn="l" indent="0" marL="0">
+            <a:pPr marL="0" indent="0" algn="l">
               <a:lnSpc>
                 <a:spcPct val="117000"/>
               </a:lnSpc>
@@ -2730,17 +2536,17 @@
       </p:sp>
       <p:pic>
         <p:nvPicPr>
-          <p:cNvPr id="15" name="Image 3" descr="preencoded.png">    </p:cNvPr>
+          <p:cNvPr id="15" name="Image 3" descr="preencoded.png"/>
           <p:cNvPicPr>
             <a:picLocks noChangeAspect="1"/>
           </p:cNvPicPr>
           <p:nvPr/>
         </p:nvPicPr>
         <p:blipFill>
-          <a:blip r:embed="rId6">
+          <a:blip>
             <a:extLst>
               <a:ext uri="{96DAC541-7B7A-43D3-8B79-37D633B846F1}">
-                <asvg:svgBlip xmlns:asvg="http://schemas.microsoft.com/office/drawing/2016/SVG/main" r:embed="rId7"/>
+                <asvg:svgBlip xmlns:asvg="http://schemas.microsoft.com/office/drawing/2016/SVG/main" r:embed="rId4"/>
               </a:ext>
             </a:extLst>
           </a:blip>
@@ -2779,7 +2585,7 @@
           <a:bodyPr wrap="none" lIns="0" tIns="0" rIns="0" bIns="0" rtlCol="0" anchor="t"/>
           <a:lstStyle/>
           <a:p>
-            <a:pPr algn="l" indent="0" marL="0">
+            <a:pPr marL="0" indent="0" algn="l">
               <a:lnSpc>
                 <a:spcPct val="104000"/>
               </a:lnSpc>
@@ -2823,7 +2629,7 @@
           </a:bodyPr>
           <a:lstStyle/>
           <a:p>
-            <a:pPr algn="l" indent="0" marL="0">
+            <a:pPr marL="0" indent="0" algn="l">
               <a:lnSpc>
                 <a:spcPct val="117000"/>
               </a:lnSpc>
@@ -2890,7 +2696,7 @@
           <a:bodyPr wrap="none" lIns="0" tIns="0" rIns="0" bIns="0" rtlCol="0" anchor="t"/>
           <a:lstStyle/>
           <a:p>
-            <a:pPr algn="l" indent="0" marL="0">
+            <a:pPr marL="0" indent="0" algn="l">
               <a:lnSpc>
                 <a:spcPct val="104000"/>
               </a:lnSpc>
@@ -2927,16 +2733,34 @@
         </p:nvGraphicFramePr>
         <p:xfrm>
           <a:off x="661475" y="1199555"/>
-          <a:ext cx="9143771" cy="914400"/>
+          <a:ext cx="5273046" cy="3424547"/>
         </p:xfrm>
         <a:graphic>
           <a:graphicData uri="http://schemas.openxmlformats.org/drawingml/2006/table">
             <a:tbl>
               <a:tblPr/>
               <a:tblGrid>
-                <a:gridCol w="1581914"/>
-                <a:gridCol w="1845566"/>
-                <a:gridCol w="1845566"/>
+                <a:gridCol w="1581914">
+                  <a:extLst>
+                    <a:ext uri="{9D8B030D-6E8A-4147-A177-3AD203B41FA5}">
+                      <a16:colId xmlns:a16="http://schemas.microsoft.com/office/drawing/2014/main" val="20000"/>
+                    </a:ext>
+                  </a:extLst>
+                </a:gridCol>
+                <a:gridCol w="1845566">
+                  <a:extLst>
+                    <a:ext uri="{9D8B030D-6E8A-4147-A177-3AD203B41FA5}">
+                      <a16:colId xmlns:a16="http://schemas.microsoft.com/office/drawing/2014/main" val="20001"/>
+                    </a:ext>
+                  </a:extLst>
+                </a:gridCol>
+                <a:gridCol w="1845566">
+                  <a:extLst>
+                    <a:ext uri="{9D8B030D-6E8A-4147-A177-3AD203B41FA5}">
+                      <a16:colId xmlns:a16="http://schemas.microsoft.com/office/drawing/2014/main" val="20002"/>
+                    </a:ext>
+                  </a:extLst>
+                </a:gridCol>
               </a:tblGrid>
               <a:tr h="306975">
                 <a:tc>
@@ -2944,7 +2768,7 @@
                     <a:bodyPr/>
                     <a:lstStyle/>
                     <a:p>
-                      <a:pPr indent="0" marL="0">
+                      <a:pPr marL="0" indent="0">
                         <a:buNone/>
                       </a:pPr>
                       <a:r>
@@ -3009,7 +2833,7 @@
                     <a:bodyPr/>
                     <a:lstStyle/>
                     <a:p>
-                      <a:pPr indent="0" marL="0">
+                      <a:pPr marL="0" indent="0">
                         <a:buNone/>
                       </a:pPr>
                       <a:r>
@@ -3074,7 +2898,7 @@
                     <a:bodyPr/>
                     <a:lstStyle/>
                     <a:p>
-                      <a:pPr indent="0" marL="0">
+                      <a:pPr marL="0" indent="0">
                         <a:buNone/>
                       </a:pPr>
                       <a:r>
@@ -3134,6 +2958,11 @@
                     </a:lnB>
                   </a:tcPr>
                 </a:tc>
+                <a:extLst>
+                  <a:ext uri="{0D108BD9-81ED-4DB2-BD59-A6C34878D82A}">
+                    <a16:rowId xmlns:a16="http://schemas.microsoft.com/office/drawing/2014/main" val="10000"/>
+                  </a:ext>
+                </a:extLst>
               </a:tr>
               <a:tr h="490128">
                 <a:tc>
@@ -3141,7 +2970,7 @@
                     <a:bodyPr/>
                     <a:lstStyle/>
                     <a:p>
-                      <a:pPr indent="0" marL="0">
+                      <a:pPr marL="0" indent="0">
                         <a:buNone/>
                       </a:pPr>
                       <a:r>
@@ -3206,7 +3035,7 @@
                     <a:bodyPr/>
                     <a:lstStyle/>
                     <a:p>
-                      <a:pPr indent="0" marL="0">
+                      <a:pPr marL="0" indent="0">
                         <a:buNone/>
                       </a:pPr>
                       <a:r>
@@ -3271,7 +3100,7 @@
                     <a:bodyPr/>
                     <a:lstStyle/>
                     <a:p>
-                      <a:pPr indent="0" marL="0">
+                      <a:pPr marL="0" indent="0">
                         <a:buNone/>
                       </a:pPr>
                       <a:r>
@@ -3331,6 +3160,11 @@
                     </a:lnB>
                   </a:tcPr>
                 </a:tc>
+                <a:extLst>
+                  <a:ext uri="{0D108BD9-81ED-4DB2-BD59-A6C34878D82A}">
+                    <a16:rowId xmlns:a16="http://schemas.microsoft.com/office/drawing/2014/main" val="10001"/>
+                  </a:ext>
+                </a:extLst>
               </a:tr>
               <a:tr h="490128">
                 <a:tc>
@@ -3338,7 +3172,7 @@
                     <a:bodyPr/>
                     <a:lstStyle/>
                     <a:p>
-                      <a:pPr indent="0" marL="0">
+                      <a:pPr marL="0" indent="0">
                         <a:buNone/>
                       </a:pPr>
                       <a:r>
@@ -3403,7 +3237,7 @@
                     <a:bodyPr/>
                     <a:lstStyle/>
                     <a:p>
-                      <a:pPr indent="0" marL="0">
+                      <a:pPr marL="0" indent="0">
                         <a:buNone/>
                       </a:pPr>
                       <a:r>
@@ -3468,7 +3302,7 @@
                     <a:bodyPr/>
                     <a:lstStyle/>
                     <a:p>
-                      <a:pPr indent="0" marL="0">
+                      <a:pPr marL="0" indent="0">
                         <a:buNone/>
                       </a:pPr>
                       <a:r>
@@ -3528,6 +3362,11 @@
                     </a:lnB>
                   </a:tcPr>
                 </a:tc>
+                <a:extLst>
+                  <a:ext uri="{0D108BD9-81ED-4DB2-BD59-A6C34878D82A}">
+                    <a16:rowId xmlns:a16="http://schemas.microsoft.com/office/drawing/2014/main" val="10002"/>
+                  </a:ext>
+                </a:extLst>
               </a:tr>
               <a:tr h="670107">
                 <a:tc>
@@ -3535,7 +3374,7 @@
                     <a:bodyPr/>
                     <a:lstStyle/>
                     <a:p>
-                      <a:pPr indent="0" marL="0">
+                      <a:pPr marL="0" indent="0">
                         <a:buNone/>
                       </a:pPr>
                       <a:r>
@@ -3600,7 +3439,7 @@
                     <a:bodyPr/>
                     <a:lstStyle/>
                     <a:p>
-                      <a:pPr indent="0" marL="0">
+                      <a:pPr marL="0" indent="0">
                         <a:buNone/>
                       </a:pPr>
                       <a:r>
@@ -3665,7 +3504,7 @@
                     <a:bodyPr/>
                     <a:lstStyle/>
                     <a:p>
-                      <a:pPr indent="0" marL="0">
+                      <a:pPr marL="0" indent="0">
                         <a:buNone/>
                       </a:pPr>
                       <a:r>
@@ -3725,6 +3564,11 @@
                     </a:lnB>
                   </a:tcPr>
                 </a:tc>
+                <a:extLst>
+                  <a:ext uri="{0D108BD9-81ED-4DB2-BD59-A6C34878D82A}">
+                    <a16:rowId xmlns:a16="http://schemas.microsoft.com/office/drawing/2014/main" val="10003"/>
+                  </a:ext>
+                </a:extLst>
               </a:tr>
               <a:tr h="490128">
                 <a:tc>
@@ -3732,7 +3576,7 @@
                     <a:bodyPr/>
                     <a:lstStyle/>
                     <a:p>
-                      <a:pPr indent="0" marL="0">
+                      <a:pPr marL="0" indent="0">
                         <a:buNone/>
                       </a:pPr>
                       <a:r>
@@ -3797,7 +3641,7 @@
                     <a:bodyPr/>
                     <a:lstStyle/>
                     <a:p>
-                      <a:pPr indent="0" marL="0">
+                      <a:pPr marL="0" indent="0">
                         <a:buNone/>
                       </a:pPr>
                       <a:r>
@@ -3862,7 +3706,7 @@
                     <a:bodyPr/>
                     <a:lstStyle/>
                     <a:p>
-                      <a:pPr indent="0" marL="0">
+                      <a:pPr marL="0" indent="0">
                         <a:buNone/>
                       </a:pPr>
                       <a:r>
@@ -3922,6 +3766,11 @@
                     </a:lnB>
                   </a:tcPr>
                 </a:tc>
+                <a:extLst>
+                  <a:ext uri="{0D108BD9-81ED-4DB2-BD59-A6C34878D82A}">
+                    <a16:rowId xmlns:a16="http://schemas.microsoft.com/office/drawing/2014/main" val="10004"/>
+                  </a:ext>
+                </a:extLst>
               </a:tr>
               <a:tr h="490128">
                 <a:tc>
@@ -3929,7 +3778,7 @@
                     <a:bodyPr/>
                     <a:lstStyle/>
                     <a:p>
-                      <a:pPr indent="0" marL="0">
+                      <a:pPr marL="0" indent="0">
                         <a:buNone/>
                       </a:pPr>
                       <a:r>
@@ -3994,7 +3843,7 @@
                     <a:bodyPr/>
                     <a:lstStyle/>
                     <a:p>
-                      <a:pPr indent="0" marL="0">
+                      <a:pPr marL="0" indent="0">
                         <a:buNone/>
                       </a:pPr>
                       <a:r>
@@ -4059,7 +3908,7 @@
                     <a:bodyPr/>
                     <a:lstStyle/>
                     <a:p>
-                      <a:pPr indent="0" marL="0">
+                      <a:pPr marL="0" indent="0">
                         <a:buNone/>
                       </a:pPr>
                       <a:r>
@@ -4119,6 +3968,11 @@
                     </a:lnB>
                   </a:tcPr>
                 </a:tc>
+                <a:extLst>
+                  <a:ext uri="{0D108BD9-81ED-4DB2-BD59-A6C34878D82A}">
+                    <a16:rowId xmlns:a16="http://schemas.microsoft.com/office/drawing/2014/main" val="10005"/>
+                  </a:ext>
+                </a:extLst>
               </a:tr>
               <a:tr h="486953">
                 <a:tc>
@@ -4126,7 +3980,7 @@
                     <a:bodyPr/>
                     <a:lstStyle/>
                     <a:p>
-                      <a:pPr indent="0" marL="0">
+                      <a:pPr marL="0" indent="0">
                         <a:buNone/>
                       </a:pPr>
                       <a:r>
@@ -4191,7 +4045,7 @@
                     <a:bodyPr/>
                     <a:lstStyle/>
                     <a:p>
-                      <a:pPr indent="0" marL="0">
+                      <a:pPr marL="0" indent="0">
                         <a:buNone/>
                       </a:pPr>
                       <a:r>
@@ -4256,7 +4110,7 @@
                     <a:bodyPr/>
                     <a:lstStyle/>
                     <a:p>
-                      <a:pPr indent="0" marL="0">
+                      <a:pPr marL="0" indent="0">
                         <a:buNone/>
                       </a:pPr>
                       <a:r>
@@ -4316,6 +4170,11 @@
                     </a:lnB>
                   </a:tcPr>
                 </a:tc>
+                <a:extLst>
+                  <a:ext uri="{0D108BD9-81ED-4DB2-BD59-A6C34878D82A}">
+                    <a16:rowId xmlns:a16="http://schemas.microsoft.com/office/drawing/2014/main" val="10006"/>
+                  </a:ext>
+                </a:extLst>
               </a:tr>
             </a:tbl>
           </a:graphicData>
@@ -4323,7 +4182,7 @@
       </p:graphicFrame>
       <p:sp>
         <p:nvSpPr>
-          <p:cNvPr id="4" name="Text 1"/>
+          <p:cNvPr id="3" name="Text 1"/>
           <p:cNvSpPr/>
           <p:nvPr/>
         </p:nvSpPr>
@@ -4342,7 +4201,7 @@
           <a:bodyPr wrap="none" lIns="0" tIns="0" rIns="0" bIns="0" rtlCol="0" anchor="t"/>
           <a:lstStyle/>
           <a:p>
-            <a:pPr algn="l" indent="0" marL="0">
+            <a:pPr marL="0" indent="0" algn="l">
               <a:lnSpc>
                 <a:spcPct val="104000"/>
               </a:lnSpc>
@@ -4386,7 +4245,7 @@
           </a:bodyPr>
           <a:lstStyle/>
           <a:p>
-            <a:pPr algn="l" indent="0" marL="0">
+            <a:pPr marL="0" indent="0" algn="l">
               <a:lnSpc>
                 <a:spcPct val="113000"/>
               </a:lnSpc>
@@ -4403,7 +4262,131 @@
               </a:rPr>
               <a:t>Quality gate:</a:t>
             </a:r>
-            <a:pPr algn="l" indent="0" marL="0">
+            <a:r>
+              <a:rPr lang="en-US" sz="1000" dirty="0">
+                <a:solidFill>
+                  <a:srgbClr val="1E3063"/>
+                </a:solidFill>
+                <a:latin typeface="Instrument Sans Medium" pitchFamily="34" charset="0"/>
+                <a:ea typeface="Instrument Sans Medium" pitchFamily="34" charset="-122"/>
+                <a:cs typeface="Instrument Sans Medium" pitchFamily="34" charset="-120"/>
+              </a:rPr>
+              <a:t> "Zero Dart Analyzer Warnings · 63/63 Automated Tests Passing · Fully Tree‑Shaken Release Build"</a:t>
+            </a:r>
+            <a:endParaRPr lang="en-US" sz="1000" dirty="0"/>
+          </a:p>
+        </p:txBody>
+      </p:sp>
+      <p:pic>
+        <p:nvPicPr>
+          <p:cNvPr id="6" name="Image 0" descr="preencoded.png"/>
+          <p:cNvPicPr>
+            <a:picLocks noChangeAspect="1"/>
+          </p:cNvPicPr>
+          <p:nvPr/>
+        </p:nvPicPr>
+        <p:blipFill>
+          <a:blip r:embed="rId3"/>
+          <a:stretch>
+            <a:fillRect/>
+          </a:stretch>
+        </p:blipFill>
+        <p:spPr>
+          <a:xfrm>
+            <a:off x="7054475" y="2098675"/>
+            <a:ext cx="3691044" cy="2091630"/>
+          </a:xfrm>
+          <a:prstGeom prst="rect">
+            <a:avLst/>
+          </a:prstGeom>
+        </p:spPr>
+      </p:pic>
+      <p:sp>
+        <p:nvSpPr>
+          <p:cNvPr id="7" name="Shape 3"/>
+          <p:cNvSpPr/>
+          <p:nvPr/>
+        </p:nvSpPr>
+        <p:spPr>
+          <a:xfrm>
+            <a:off x="661475" y="4845248"/>
+            <a:ext cx="297649" cy="297656"/>
+          </a:xfrm>
+          <a:prstGeom prst="roundRect">
+            <a:avLst>
+              <a:gd name="adj" fmla="val 40007"/>
+            </a:avLst>
+          </a:prstGeom>
+          <a:solidFill>
+            <a:srgbClr val="CEE6FD"/>
+          </a:solidFill>
+          <a:ln/>
+        </p:spPr>
+      </p:sp>
+      <p:sp>
+        <p:nvSpPr>
+          <p:cNvPr id="8" name="Text 4"/>
+          <p:cNvSpPr/>
+          <p:nvPr/>
+        </p:nvSpPr>
+        <p:spPr>
+          <a:xfrm>
+            <a:off x="1051692" y="4890691"/>
+            <a:ext cx="4986312" cy="206673"/>
+          </a:xfrm>
+          <a:prstGeom prst="rect">
+            <a:avLst/>
+          </a:prstGeom>
+          <a:noFill/>
+          <a:ln/>
+        </p:spPr>
+        <p:txBody>
+          <a:bodyPr wrap="none" lIns="0" tIns="0" rIns="0" bIns="0" rtlCol="0" anchor="t"/>
+          <a:lstStyle/>
+          <a:p>
+            <a:pPr marL="0" indent="0" algn="l">
+              <a:lnSpc>
+                <a:spcPct val="104000"/>
+              </a:lnSpc>
+              <a:buNone/>
+            </a:pPr>
+            <a:r>
+              <a:rPr lang="en-US" sz="1300" dirty="0">
+                <a:solidFill>
+                  <a:srgbClr val="1E3063"/>
+                </a:solidFill>
+                <a:latin typeface="Instrument Sans SemiBold" pitchFamily="34" charset="0"/>
+                <a:ea typeface="Instrument Sans SemiBold" pitchFamily="34" charset="-122"/>
+                <a:cs typeface="Instrument Sans SemiBold" pitchFamily="34" charset="-120"/>
+              </a:rPr>
+              <a:t>Hardware‑Backed Biometric Lock</a:t>
+            </a:r>
+            <a:endParaRPr lang="en-US" sz="1300" dirty="0"/>
+          </a:p>
+        </p:txBody>
+      </p:sp>
+      <p:sp>
+        <p:nvSpPr>
+          <p:cNvPr id="9" name="Text 5"/>
+          <p:cNvSpPr/>
+          <p:nvPr/>
+        </p:nvSpPr>
+        <p:spPr>
+          <a:xfrm>
+            <a:off x="1051692" y="5152926"/>
+            <a:ext cx="4986312" cy="179983"/>
+          </a:xfrm>
+          <a:prstGeom prst="rect">
+            <a:avLst/>
+          </a:prstGeom>
+          <a:noFill/>
+          <a:ln/>
+        </p:spPr>
+        <p:txBody>
+          <a:bodyPr wrap="none" lIns="0" tIns="0" rIns="0" bIns="0" rtlCol="0" anchor="t"/>
+          <a:lstStyle/>
+          <a:p>
+            <a:pPr marL="0" indent="0" algn="l">
               <a:lnSpc>
                 <a:spcPct val="113000"/>
               </a:lnSpc>
@@ -4418,45 +4401,21 @@
                 <a:ea typeface="Instrument Sans Medium" pitchFamily="34" charset="-122"/>
                 <a:cs typeface="Instrument Sans Medium" pitchFamily="34" charset="-120"/>
               </a:rPr>
-              <a:t> "Zero Dart Analyzer Warnings · 63/63 Automated Tests Passing · Fully Tree‑Shaken Release Build"</a:t>
+              <a:t>Fingerprint and face unlock with device PIN fallback and lifecycle resume guards.</a:t>
             </a:r>
             <a:endParaRPr lang="en-US" sz="1000" dirty="0"/>
           </a:p>
         </p:txBody>
       </p:sp>
-      <p:pic>
-        <p:nvPicPr>
-          <p:cNvPr id="6" name="Image 0" descr="preencoded.png">    </p:cNvPr>
-          <p:cNvPicPr>
-            <a:picLocks noChangeAspect="1"/>
-          </p:cNvPicPr>
-          <p:nvPr/>
-        </p:nvPicPr>
-        <p:blipFill>
-          <a:blip r:embed="rId1"/>
-          <a:stretch>
-            <a:fillRect/>
-          </a:stretch>
-        </p:blipFill>
-        <p:spPr>
-          <a:xfrm>
-            <a:off x="7054475" y="2098675"/>
-            <a:ext cx="3691044" cy="2091630"/>
-          </a:xfrm>
-          <a:prstGeom prst="rect">
-            <a:avLst/>
-          </a:prstGeom>
-        </p:spPr>
-      </p:pic>
-      <p:sp>
-        <p:nvSpPr>
-          <p:cNvPr id="7" name="Shape 3"/>
-          <p:cNvSpPr/>
-          <p:nvPr/>
-        </p:nvSpPr>
-        <p:spPr>
-          <a:xfrm>
-            <a:off x="661475" y="4845248"/>
+      <p:sp>
+        <p:nvSpPr>
+          <p:cNvPr id="10" name="Shape 6"/>
+          <p:cNvSpPr/>
+          <p:nvPr/>
+        </p:nvSpPr>
+        <p:spPr>
+          <a:xfrm>
+            <a:off x="6153691" y="4845248"/>
             <a:ext cx="297649" cy="297656"/>
           </a:xfrm>
           <a:prstGeom prst="roundRect">
@@ -4472,13 +4431,13 @@
       </p:sp>
       <p:sp>
         <p:nvSpPr>
-          <p:cNvPr id="8" name="Text 4"/>
-          <p:cNvSpPr/>
-          <p:nvPr/>
-        </p:nvSpPr>
-        <p:spPr>
-          <a:xfrm>
-            <a:off x="1051692" y="4890691"/>
+          <p:cNvPr id="11" name="Text 7"/>
+          <p:cNvSpPr/>
+          <p:nvPr/>
+        </p:nvSpPr>
+        <p:spPr>
+          <a:xfrm>
+            <a:off x="6543908" y="4890691"/>
             <a:ext cx="4986312" cy="206673"/>
           </a:xfrm>
           <a:prstGeom prst="rect">
@@ -4491,7 +4450,7 @@
           <a:bodyPr wrap="none" lIns="0" tIns="0" rIns="0" bIns="0" rtlCol="0" anchor="t"/>
           <a:lstStyle/>
           <a:p>
-            <a:pPr algn="l" indent="0" marL="0">
+            <a:pPr marL="0" indent="0" algn="l">
               <a:lnSpc>
                 <a:spcPct val="104000"/>
               </a:lnSpc>
@@ -4506,7 +4465,7 @@
                 <a:ea typeface="Instrument Sans SemiBold" pitchFamily="34" charset="-122"/>
                 <a:cs typeface="Instrument Sans SemiBold" pitchFamily="34" charset="-120"/>
               </a:rPr>
-              <a:t>Hardware‑Backed Biometric Lock</a:t>
+              <a:t>Row‑Level Security (RLS)</a:t>
             </a:r>
             <a:endParaRPr lang="en-US" sz="1300" dirty="0"/>
           </a:p>
@@ -4514,14 +4473,14 @@
       </p:sp>
       <p:sp>
         <p:nvSpPr>
-          <p:cNvPr id="9" name="Text 5"/>
-          <p:cNvSpPr/>
-          <p:nvPr/>
-        </p:nvSpPr>
-        <p:spPr>
-          <a:xfrm>
-            <a:off x="1051692" y="5152926"/>
-            <a:ext cx="4986312" cy="179983"/>
+          <p:cNvPr id="12" name="Text 8"/>
+          <p:cNvSpPr/>
+          <p:nvPr/>
+        </p:nvSpPr>
+        <p:spPr>
+          <a:xfrm>
+            <a:off x="6543908" y="5152926"/>
+            <a:ext cx="4986312" cy="359966"/>
           </a:xfrm>
           <a:prstGeom prst="rect">
             <a:avLst/>
@@ -4530,10 +4489,12 @@
           <a:ln/>
         </p:spPr>
         <p:txBody>
-          <a:bodyPr wrap="none" lIns="0" tIns="0" rIns="0" bIns="0" rtlCol="0" anchor="t"/>
-          <a:lstStyle/>
-          <a:p>
-            <a:pPr algn="l" indent="0" marL="0">
+          <a:bodyPr wrap="square" lIns="0" tIns="0" rIns="0" bIns="0" rtlCol="0" anchor="t">
+            <a:normAutofit/>
+          </a:bodyPr>
+          <a:lstStyle/>
+          <a:p>
+            <a:pPr marL="0" indent="0" algn="l">
               <a:lnSpc>
                 <a:spcPct val="113000"/>
               </a:lnSpc>
@@ -4548,7 +4509,7 @@
                 <a:ea typeface="Instrument Sans Medium" pitchFamily="34" charset="-122"/>
                 <a:cs typeface="Instrument Sans Medium" pitchFamily="34" charset="-120"/>
               </a:rPr>
-              <a:t>Fingerprint and face unlock with device PIN fallback and lifecycle resume guards.</a:t>
+              <a:t>Strict PostgreSQL policies enforce least privilege per role (citizen, field worker, admin).</a:t>
             </a:r>
             <a:endParaRPr lang="en-US" sz="1000" dirty="0"/>
           </a:p>
@@ -4556,13 +4517,13 @@
       </p:sp>
       <p:sp>
         <p:nvSpPr>
-          <p:cNvPr id="10" name="Shape 6"/>
-          <p:cNvSpPr/>
-          <p:nvPr/>
-        </p:nvSpPr>
-        <p:spPr>
-          <a:xfrm>
-            <a:off x="6153691" y="4845248"/>
+          <p:cNvPr id="13" name="Shape 9"/>
+          <p:cNvSpPr/>
+          <p:nvPr/>
+        </p:nvSpPr>
+        <p:spPr>
+          <a:xfrm>
+            <a:off x="661475" y="5698133"/>
             <a:ext cx="297649" cy="297656"/>
           </a:xfrm>
           <a:prstGeom prst="roundRect">
@@ -4578,13 +4539,13 @@
       </p:sp>
       <p:sp>
         <p:nvSpPr>
-          <p:cNvPr id="11" name="Text 7"/>
-          <p:cNvSpPr/>
-          <p:nvPr/>
-        </p:nvSpPr>
-        <p:spPr>
-          <a:xfrm>
-            <a:off x="6543908" y="4890691"/>
+          <p:cNvPr id="14" name="Text 10"/>
+          <p:cNvSpPr/>
+          <p:nvPr/>
+        </p:nvSpPr>
+        <p:spPr>
+          <a:xfrm>
+            <a:off x="1051692" y="5743575"/>
             <a:ext cx="4986312" cy="206673"/>
           </a:xfrm>
           <a:prstGeom prst="rect">
@@ -4597,7 +4558,7 @@
           <a:bodyPr wrap="none" lIns="0" tIns="0" rIns="0" bIns="0" rtlCol="0" anchor="t"/>
           <a:lstStyle/>
           <a:p>
-            <a:pPr algn="l" indent="0" marL="0">
+            <a:pPr marL="0" indent="0" algn="l">
               <a:lnSpc>
                 <a:spcPct val="104000"/>
               </a:lnSpc>
@@ -4612,7 +4573,7 @@
                 <a:ea typeface="Instrument Sans SemiBold" pitchFamily="34" charset="-122"/>
                 <a:cs typeface="Instrument Sans SemiBold" pitchFamily="34" charset="-120"/>
               </a:rPr>
-              <a:t>Row‑Level Security (RLS)</a:t>
+              <a:t>Atomic SECURITY DEFINER RPCs</a:t>
             </a:r>
             <a:endParaRPr lang="en-US" sz="1300" dirty="0"/>
           </a:p>
@@ -4620,14 +4581,14 @@
       </p:sp>
       <p:sp>
         <p:nvSpPr>
-          <p:cNvPr id="12" name="Text 8"/>
-          <p:cNvSpPr/>
-          <p:nvPr/>
-        </p:nvSpPr>
-        <p:spPr>
-          <a:xfrm>
-            <a:off x="6543908" y="5152926"/>
-            <a:ext cx="4986312" cy="359966"/>
+          <p:cNvPr id="15" name="Text 11"/>
+          <p:cNvSpPr/>
+          <p:nvPr/>
+        </p:nvSpPr>
+        <p:spPr>
+          <a:xfrm>
+            <a:off x="1051692" y="6005810"/>
+            <a:ext cx="4986312" cy="179983"/>
           </a:xfrm>
           <a:prstGeom prst="rect">
             <a:avLst/>
@@ -4636,12 +4597,10 @@
           <a:ln/>
         </p:spPr>
         <p:txBody>
-          <a:bodyPr wrap="square" lIns="0" tIns="0" rIns="0" bIns="0" rtlCol="0" anchor="t">
-            <a:normAutofit/>
-          </a:bodyPr>
-          <a:lstStyle/>
-          <a:p>
-            <a:pPr algn="l" indent="0" marL="0">
+          <a:bodyPr wrap="none" lIns="0" tIns="0" rIns="0" bIns="0" rtlCol="0" anchor="t"/>
+          <a:lstStyle/>
+          <a:p>
+            <a:pPr marL="0" indent="0" algn="l">
               <a:lnSpc>
                 <a:spcPct val="113000"/>
               </a:lnSpc>
@@ -4656,7 +4615,7 @@
                 <a:ea typeface="Instrument Sans Medium" pitchFamily="34" charset="-122"/>
                 <a:cs typeface="Instrument Sans Medium" pitchFamily="34" charset="-120"/>
               </a:rPr>
-              <a:t>Strict PostgreSQL policies enforce least privilege per role (citizen, field worker, admin).</a:t>
+              <a:t>Server‑side transactional integrity for claim handovers and status updates.</a:t>
             </a:r>
             <a:endParaRPr lang="en-US" sz="1000" dirty="0"/>
           </a:p>
@@ -4664,13 +4623,13 @@
       </p:sp>
       <p:sp>
         <p:nvSpPr>
-          <p:cNvPr id="13" name="Shape 9"/>
-          <p:cNvSpPr/>
-          <p:nvPr/>
-        </p:nvSpPr>
-        <p:spPr>
-          <a:xfrm>
-            <a:off x="661475" y="5698133"/>
+          <p:cNvPr id="16" name="Shape 12"/>
+          <p:cNvSpPr/>
+          <p:nvPr/>
+        </p:nvSpPr>
+        <p:spPr>
+          <a:xfrm>
+            <a:off x="6153691" y="5698133"/>
             <a:ext cx="297649" cy="297656"/>
           </a:xfrm>
           <a:prstGeom prst="roundRect">
@@ -4686,13 +4645,13 @@
       </p:sp>
       <p:sp>
         <p:nvSpPr>
-          <p:cNvPr id="14" name="Text 10"/>
-          <p:cNvSpPr/>
-          <p:nvPr/>
-        </p:nvSpPr>
-        <p:spPr>
-          <a:xfrm>
-            <a:off x="1051692" y="5743575"/>
+          <p:cNvPr id="17" name="Text 13"/>
+          <p:cNvSpPr/>
+          <p:nvPr/>
+        </p:nvSpPr>
+        <p:spPr>
+          <a:xfrm>
+            <a:off x="6543908" y="5743575"/>
             <a:ext cx="4986312" cy="206673"/>
           </a:xfrm>
           <a:prstGeom prst="rect">
@@ -4705,7 +4664,7 @@
           <a:bodyPr wrap="none" lIns="0" tIns="0" rIns="0" bIns="0" rtlCol="0" anchor="t"/>
           <a:lstStyle/>
           <a:p>
-            <a:pPr algn="l" indent="0" marL="0">
+            <a:pPr marL="0" indent="0" algn="l">
               <a:lnSpc>
                 <a:spcPct val="104000"/>
               </a:lnSpc>
@@ -4720,112 +4679,6 @@
                 <a:ea typeface="Instrument Sans SemiBold" pitchFamily="34" charset="-122"/>
                 <a:cs typeface="Instrument Sans SemiBold" pitchFamily="34" charset="-120"/>
               </a:rPr>
-              <a:t>Atomic SECURITY DEFINER RPCs</a:t>
-            </a:r>
-            <a:endParaRPr lang="en-US" sz="1300" dirty="0"/>
-          </a:p>
-        </p:txBody>
-      </p:sp>
-      <p:sp>
-        <p:nvSpPr>
-          <p:cNvPr id="15" name="Text 11"/>
-          <p:cNvSpPr/>
-          <p:nvPr/>
-        </p:nvSpPr>
-        <p:spPr>
-          <a:xfrm>
-            <a:off x="1051692" y="6005810"/>
-            <a:ext cx="4986312" cy="179983"/>
-          </a:xfrm>
-          <a:prstGeom prst="rect">
-            <a:avLst/>
-          </a:prstGeom>
-          <a:noFill/>
-          <a:ln/>
-        </p:spPr>
-        <p:txBody>
-          <a:bodyPr wrap="none" lIns="0" tIns="0" rIns="0" bIns="0" rtlCol="0" anchor="t"/>
-          <a:lstStyle/>
-          <a:p>
-            <a:pPr algn="l" indent="0" marL="0">
-              <a:lnSpc>
-                <a:spcPct val="113000"/>
-              </a:lnSpc>
-              <a:buNone/>
-            </a:pPr>
-            <a:r>
-              <a:rPr lang="en-US" sz="1000" dirty="0">
-                <a:solidFill>
-                  <a:srgbClr val="1E3063"/>
-                </a:solidFill>
-                <a:latin typeface="Instrument Sans Medium" pitchFamily="34" charset="0"/>
-                <a:ea typeface="Instrument Sans Medium" pitchFamily="34" charset="-122"/>
-                <a:cs typeface="Instrument Sans Medium" pitchFamily="34" charset="-120"/>
-              </a:rPr>
-              <a:t>Server‑side transactional integrity for claim handovers and status updates.</a:t>
-            </a:r>
-            <a:endParaRPr lang="en-US" sz="1000" dirty="0"/>
-          </a:p>
-        </p:txBody>
-      </p:sp>
-      <p:sp>
-        <p:nvSpPr>
-          <p:cNvPr id="16" name="Shape 12"/>
-          <p:cNvSpPr/>
-          <p:nvPr/>
-        </p:nvSpPr>
-        <p:spPr>
-          <a:xfrm>
-            <a:off x="6153691" y="5698133"/>
-            <a:ext cx="297649" cy="297656"/>
-          </a:xfrm>
-          <a:prstGeom prst="roundRect">
-            <a:avLst>
-              <a:gd name="adj" fmla="val 40007"/>
-            </a:avLst>
-          </a:prstGeom>
-          <a:solidFill>
-            <a:srgbClr val="CEE6FD"/>
-          </a:solidFill>
-          <a:ln/>
-        </p:spPr>
-      </p:sp>
-      <p:sp>
-        <p:nvSpPr>
-          <p:cNvPr id="17" name="Text 13"/>
-          <p:cNvSpPr/>
-          <p:nvPr/>
-        </p:nvSpPr>
-        <p:spPr>
-          <a:xfrm>
-            <a:off x="6543908" y="5743575"/>
-            <a:ext cx="4986312" cy="206673"/>
-          </a:xfrm>
-          <a:prstGeom prst="rect">
-            <a:avLst/>
-          </a:prstGeom>
-          <a:noFill/>
-          <a:ln/>
-        </p:spPr>
-        <p:txBody>
-          <a:bodyPr wrap="none" lIns="0" tIns="0" rIns="0" bIns="0" rtlCol="0" anchor="t"/>
-          <a:lstStyle/>
-          <a:p>
-            <a:pPr algn="l" indent="0" marL="0">
-              <a:lnSpc>
-                <a:spcPct val="104000"/>
-              </a:lnSpc>
-              <a:buNone/>
-            </a:pPr>
-            <a:r>
-              <a:rPr lang="en-US" sz="1300" dirty="0">
-                <a:solidFill>
-                  <a:srgbClr val="1E3063"/>
-                </a:solidFill>
-                <a:latin typeface="Instrument Sans SemiBold" pitchFamily="34" charset="0"/>
-                <a:ea typeface="Instrument Sans SemiBold" pitchFamily="34" charset="-122"/>
-                <a:cs typeface="Instrument Sans SemiBold" pitchFamily="34" charset="-120"/>
-              </a:rPr>
               <a:t>Offline‑First Queue</a:t>
             </a:r>
             <a:endParaRPr lang="en-US" sz="1300" dirty="0"/>
@@ -4853,7 +4706,7 @@
           <a:bodyPr wrap="none" lIns="0" tIns="0" rIns="0" bIns="0" rtlCol="0" anchor="t"/>
           <a:lstStyle/>
           <a:p>
-            <a:pPr algn="l" indent="0" marL="0">
+            <a:pPr marL="0" indent="0" algn="l">
               <a:lnSpc>
                 <a:spcPct val="113000"/>
               </a:lnSpc>
@@ -4920,7 +4773,7 @@
           <a:bodyPr wrap="none" lIns="0" tIns="0" rIns="0" bIns="0" rtlCol="0" anchor="t"/>
           <a:lstStyle/>
           <a:p>
-            <a:pPr algn="l" indent="0" marL="0">
+            <a:pPr marL="0" indent="0" algn="l">
               <a:lnSpc>
                 <a:spcPct val="104000"/>
               </a:lnSpc>
@@ -4943,263 +4796,7 @@
       </p:sp>
       <p:pic>
         <p:nvPicPr>
-          <p:cNvPr id="3" name="Image 0" descr="preencoded.png">    </p:cNvPr>
-          <p:cNvPicPr>
-            <a:picLocks noChangeAspect="1"/>
-          </p:cNvPicPr>
-          <p:nvPr/>
-        </p:nvPicPr>
-        <p:blipFill>
-          <a:blip r:embed="rId1"/>
-          <a:stretch>
-            <a:fillRect/>
-          </a:stretch>
-        </p:blipFill>
-        <p:spPr>
-          <a:xfrm>
-            <a:off x="661475" y="1294408"/>
-            <a:ext cx="719715" cy="899616"/>
-          </a:xfrm>
-          <a:prstGeom prst="rect">
-            <a:avLst/>
-          </a:prstGeom>
-        </p:spPr>
-      </p:pic>
-      <p:sp>
-        <p:nvSpPr>
-          <p:cNvPr id="4" name="Text 1"/>
-          <p:cNvSpPr/>
-          <p:nvPr/>
-        </p:nvSpPr>
-        <p:spPr>
-          <a:xfrm>
-            <a:off x="1496876" y="1294408"/>
-            <a:ext cx="2710390" cy="206673"/>
-          </a:xfrm>
-          <a:prstGeom prst="rect">
-            <a:avLst/>
-          </a:prstGeom>
-          <a:noFill/>
-          <a:ln/>
-        </p:spPr>
-        <p:txBody>
-          <a:bodyPr wrap="none" lIns="0" tIns="0" rIns="0" bIns="0" rtlCol="0" anchor="t"/>
-          <a:lstStyle/>
-          <a:p>
-            <a:pPr algn="l" indent="0" marL="0">
-              <a:lnSpc>
-                <a:spcPct val="104000"/>
-              </a:lnSpc>
-              <a:buNone/>
-            </a:pPr>
-            <a:r>
-              <a:rPr lang="en-US" sz="1300" dirty="0">
-                <a:solidFill>
-                  <a:srgbClr val="1E3063"/>
-                </a:solidFill>
-                <a:latin typeface="Instrument Sans SemiBold" pitchFamily="34" charset="0"/>
-                <a:ea typeface="Instrument Sans SemiBold" pitchFamily="34" charset="-122"/>
-                <a:cs typeface="Instrument Sans SemiBold" pitchFamily="34" charset="-120"/>
-              </a:rPr>
-              <a:t>Tri‑lingual Experience</a:t>
-            </a:r>
-            <a:endParaRPr lang="en-US" sz="1300" dirty="0"/>
-          </a:p>
-        </p:txBody>
-      </p:sp>
-      <p:sp>
-        <p:nvSpPr>
-          <p:cNvPr id="5" name="Text 2"/>
-          <p:cNvSpPr/>
-          <p:nvPr/>
-        </p:nvSpPr>
-        <p:spPr>
-          <a:xfrm>
-            <a:off x="1496876" y="1556643"/>
-            <a:ext cx="2710390" cy="899914"/>
-          </a:xfrm>
-          <a:prstGeom prst="rect">
-            <a:avLst/>
-          </a:prstGeom>
-          <a:noFill/>
-          <a:ln/>
-        </p:spPr>
-        <p:txBody>
-          <a:bodyPr wrap="square" lIns="0" tIns="0" rIns="0" bIns="0" rtlCol="0" anchor="t">
-            <a:normAutofit/>
-          </a:bodyPr>
-          <a:lstStyle/>
-          <a:p>
-            <a:pPr algn="l" indent="0" marL="0">
-              <a:lnSpc>
-                <a:spcPct val="113000"/>
-              </a:lnSpc>
-              <a:buNone/>
-            </a:pPr>
-            <a:r>
-              <a:rPr lang="hi-IN" altLang="en-US" sz="1000" dirty="0">
-                <a:solidFill>
-                  <a:srgbClr val="1E3063"/>
-                </a:solidFill>
-                <a:latin typeface="Instrument Sans Medium" pitchFamily="34" charset="0"/>
-                <a:ea typeface="Instrument Sans Medium" pitchFamily="34" charset="-122"/>
-                <a:cs typeface="Instrument Sans Medium" pitchFamily="34" charset="-120"/>
-              </a:rPr>
-              <a:t>One‑tap switching between English, हिंदी (Hindi) and മലയാളം (Malayalam). Full localization across 19 civic categories; extended support for 22 scheduled languages with native typography.</a:t>
-            </a:r>
-            <a:endParaRPr lang="hi-IN" sz="1000" dirty="0"/>
-          </a:p>
-        </p:txBody>
-      </p:sp>
-      <p:pic>
-        <p:nvPicPr>
-          <p:cNvPr id="6" name="Image 1" descr="preencoded.png">    </p:cNvPr>
-          <p:cNvPicPr>
-            <a:picLocks noChangeAspect="1"/>
-          </p:cNvPicPr>
-          <p:nvPr/>
-        </p:nvPicPr>
-        <p:blipFill>
-          <a:blip r:embed="rId2"/>
-          <a:stretch>
-            <a:fillRect/>
-          </a:stretch>
-        </p:blipFill>
-        <p:spPr>
-          <a:xfrm>
-            <a:off x="4322952" y="1294408"/>
-            <a:ext cx="719715" cy="899616"/>
-          </a:xfrm>
-          <a:prstGeom prst="rect">
-            <a:avLst/>
-          </a:prstGeom>
-        </p:spPr>
-      </p:pic>
-      <p:sp>
-        <p:nvSpPr>
-          <p:cNvPr id="7" name="Text 3"/>
-          <p:cNvSpPr/>
-          <p:nvPr/>
-        </p:nvSpPr>
-        <p:spPr>
-          <a:xfrm>
-            <a:off x="5158353" y="1294408"/>
-            <a:ext cx="2710390" cy="413345"/>
-          </a:xfrm>
-          <a:prstGeom prst="rect">
-            <a:avLst/>
-          </a:prstGeom>
-          <a:noFill/>
-          <a:ln/>
-        </p:spPr>
-        <p:txBody>
-          <a:bodyPr wrap="square" lIns="0" tIns="0" rIns="0" bIns="0" rtlCol="0" anchor="t">
-            <a:normAutofit/>
-          </a:bodyPr>
-          <a:lstStyle/>
-          <a:p>
-            <a:pPr algn="l" indent="0" marL="0">
-              <a:lnSpc>
-                <a:spcPct val="104000"/>
-              </a:lnSpc>
-              <a:buNone/>
-            </a:pPr>
-            <a:r>
-              <a:rPr lang="en-US" sz="1300" dirty="0">
-                <a:solidFill>
-                  <a:srgbClr val="1E3063"/>
-                </a:solidFill>
-                <a:latin typeface="Instrument Sans SemiBold" pitchFamily="34" charset="0"/>
-                <a:ea typeface="Instrument Sans SemiBold" pitchFamily="34" charset="-122"/>
-                <a:cs typeface="Instrument Sans SemiBold" pitchFamily="34" charset="-120"/>
-              </a:rPr>
-              <a:t>WCAG AAA Dark Glassmorphic Aesthetics</a:t>
-            </a:r>
-            <a:endParaRPr lang="en-US" sz="1300" dirty="0"/>
-          </a:p>
-        </p:txBody>
-      </p:sp>
-      <p:sp>
-        <p:nvSpPr>
-          <p:cNvPr id="8" name="Text 4"/>
-          <p:cNvSpPr/>
-          <p:nvPr/>
-        </p:nvSpPr>
-        <p:spPr>
-          <a:xfrm>
-            <a:off x="5158353" y="1763316"/>
-            <a:ext cx="2710390" cy="719931"/>
-          </a:xfrm>
-          <a:prstGeom prst="rect">
-            <a:avLst/>
-          </a:prstGeom>
-          <a:noFill/>
-          <a:ln/>
-        </p:spPr>
-        <p:txBody>
-          <a:bodyPr wrap="square" lIns="0" tIns="0" rIns="0" bIns="0" rtlCol="0" anchor="t">
-            <a:normAutofit/>
-          </a:bodyPr>
-          <a:lstStyle/>
-          <a:p>
-            <a:pPr algn="l" indent="0" marL="0">
-              <a:lnSpc>
-                <a:spcPct val="113000"/>
-              </a:lnSpc>
-              <a:buNone/>
-            </a:pPr>
-            <a:r>
-              <a:rPr lang="en-US" sz="1000" dirty="0">
-                <a:solidFill>
-                  <a:srgbClr val="1E3063"/>
-                </a:solidFill>
-                <a:latin typeface="Instrument Sans Medium" pitchFamily="34" charset="0"/>
-                <a:ea typeface="Instrument Sans Medium" pitchFamily="34" charset="-122"/>
-                <a:cs typeface="Instrument Sans Medium" pitchFamily="34" charset="-120"/>
-              </a:rPr>
-              <a:t>Deep backgrounds with luminous accents ensure legibility in harsh daylight and night. Palette tuned for accessibility and brand: </a:t>
-            </a:r>
-            <a:pPr algn="l" indent="0" marL="0">
-              <a:lnSpc>
-                <a:spcPct val="113000"/>
-              </a:lnSpc>
-              <a:buNone/>
-            </a:pPr>
-            <a:r>
-              <a:rPr lang="en-US" sz="1000" dirty="0">
-                <a:solidFill>
-                  <a:srgbClr val="84C1FA"/>
-                </a:solidFill>
-                <a:latin typeface="Instrument Sans Medium" pitchFamily="34" charset="0"/>
-                <a:ea typeface="Instrument Sans Medium" pitchFamily="34" charset="-122"/>
-                <a:cs typeface="Instrument Sans Medium" pitchFamily="34" charset="-120"/>
-              </a:rPr>
-              <a:t>#84C1FA</a:t>
-            </a:r>
-            <a:pPr algn="l" indent="0" marL="0">
-              <a:lnSpc>
-                <a:spcPct val="113000"/>
-              </a:lnSpc>
-              <a:buNone/>
-            </a:pPr>
-            <a:r>
-              <a:rPr lang="en-US" sz="1000" dirty="0">
-                <a:solidFill>
-                  <a:srgbClr val="1E3063"/>
-                </a:solidFill>
-                <a:latin typeface="Instrument Sans Medium" pitchFamily="34" charset="0"/>
-                <a:ea typeface="Instrument Sans Medium" pitchFamily="34" charset="-122"/>
-                <a:cs typeface="Instrument Sans Medium" pitchFamily="34" charset="-120"/>
-              </a:rPr>
-              <a:t> accent.</a:t>
-            </a:r>
-            <a:endParaRPr lang="en-US" sz="1000" dirty="0"/>
-          </a:p>
-        </p:txBody>
-      </p:sp>
-      <p:pic>
-        <p:nvPicPr>
-          <p:cNvPr id="9" name="Image 2" descr="preencoded.png">    </p:cNvPr>
+          <p:cNvPr id="3" name="Image 0" descr="preencoded.png"/>
           <p:cNvPicPr>
             <a:picLocks noChangeAspect="1"/>
           </p:cNvPicPr>
@@ -5213,7 +4810,7 @@
         </p:blipFill>
         <p:spPr>
           <a:xfrm>
-            <a:off x="7984429" y="1294408"/>
+            <a:off x="661475" y="1294408"/>
             <a:ext cx="719715" cy="899616"/>
           </a:xfrm>
           <a:prstGeom prst="rect">
@@ -5223,13 +4820,13 @@
       </p:pic>
       <p:sp>
         <p:nvSpPr>
-          <p:cNvPr id="10" name="Text 5"/>
-          <p:cNvSpPr/>
-          <p:nvPr/>
-        </p:nvSpPr>
-        <p:spPr>
-          <a:xfrm>
-            <a:off x="8819830" y="1294408"/>
+          <p:cNvPr id="4" name="Text 1"/>
+          <p:cNvSpPr/>
+          <p:nvPr/>
+        </p:nvSpPr>
+        <p:spPr>
+          <a:xfrm>
+            <a:off x="1496876" y="1294408"/>
             <a:ext cx="2710390" cy="206673"/>
           </a:xfrm>
           <a:prstGeom prst="rect">
@@ -5242,7 +4839,7 @@
           <a:bodyPr wrap="none" lIns="0" tIns="0" rIns="0" bIns="0" rtlCol="0" anchor="t"/>
           <a:lstStyle/>
           <a:p>
-            <a:pPr algn="l" indent="0" marL="0">
+            <a:pPr marL="0" indent="0" algn="l">
               <a:lnSpc>
                 <a:spcPct val="104000"/>
               </a:lnSpc>
@@ -5257,7 +4854,7 @@
                 <a:ea typeface="Instrument Sans SemiBold" pitchFamily="34" charset="-122"/>
                 <a:cs typeface="Instrument Sans SemiBold" pitchFamily="34" charset="-120"/>
               </a:rPr>
-              <a:t>Natural Motion &amp; Haptics</a:t>
+              <a:t>Tri‑lingual Experience</a:t>
             </a:r>
             <a:endParaRPr lang="en-US" sz="1300" dirty="0"/>
           </a:p>
@@ -5265,14 +4862,14 @@
       </p:sp>
       <p:sp>
         <p:nvSpPr>
-          <p:cNvPr id="11" name="Text 6"/>
-          <p:cNvSpPr/>
-          <p:nvPr/>
-        </p:nvSpPr>
-        <p:spPr>
-          <a:xfrm>
-            <a:off x="8819830" y="1556643"/>
-            <a:ext cx="2710390" cy="539948"/>
+          <p:cNvPr id="5" name="Text 2"/>
+          <p:cNvSpPr/>
+          <p:nvPr/>
+        </p:nvSpPr>
+        <p:spPr>
+          <a:xfrm>
+            <a:off x="1496876" y="1556643"/>
+            <a:ext cx="2710390" cy="899914"/>
           </a:xfrm>
           <a:prstGeom prst="rect">
             <a:avLst/>
@@ -5286,14 +4883,14 @@
           </a:bodyPr>
           <a:lstStyle/>
           <a:p>
-            <a:pPr algn="l" indent="0" marL="0">
+            <a:pPr marL="0" indent="0" algn="l">
               <a:lnSpc>
                 <a:spcPct val="113000"/>
               </a:lnSpc>
               <a:buNone/>
             </a:pPr>
             <a:r>
-              <a:rPr lang="en-US" sz="1000" dirty="0">
+              <a:rPr lang="hi-IN" altLang="en-US" sz="1000" dirty="0">
                 <a:solidFill>
                   <a:srgbClr val="1E3063"/>
                 </a:solidFill>
@@ -5301,101 +4898,15 @@
                 <a:ea typeface="Instrument Sans Medium" pitchFamily="34" charset="-122"/>
                 <a:cs typeface="Instrument Sans Medium" pitchFamily="34" charset="-120"/>
               </a:rPr>
-              <a:t>Emil Kowalski spring dynamics: tactile haptics and physical scaling on tap for predictable, humane interactions.</a:t>
-            </a:r>
-            <a:endParaRPr lang="en-US" sz="1000" dirty="0"/>
-          </a:p>
-        </p:txBody>
-      </p:sp>
-      <p:sp>
-        <p:nvSpPr>
-          <p:cNvPr id="12" name="Text 7"/>
-          <p:cNvSpPr/>
-          <p:nvPr/>
-        </p:nvSpPr>
-        <p:spPr>
-          <a:xfrm>
-            <a:off x="661475" y="3565327"/>
-            <a:ext cx="3594308" cy="206673"/>
-          </a:xfrm>
-          <a:prstGeom prst="rect">
-            <a:avLst/>
-          </a:prstGeom>
-          <a:noFill/>
-          <a:ln/>
-        </p:spPr>
-        <p:txBody>
-          <a:bodyPr wrap="none" lIns="0" tIns="0" rIns="0" bIns="0" rtlCol="0" anchor="t"/>
-          <a:lstStyle/>
-          <a:p>
-            <a:pPr algn="l" indent="0" marL="0">
-              <a:lnSpc>
-                <a:spcPct val="104000"/>
-              </a:lnSpc>
-              <a:buNone/>
-            </a:pPr>
-            <a:r>
-              <a:rPr lang="en-US" sz="1300" dirty="0">
-                <a:solidFill>
-                  <a:srgbClr val="091C53"/>
-                </a:solidFill>
-                <a:latin typeface="Instrument Sans SemiBold" pitchFamily="34" charset="0"/>
-                <a:ea typeface="Instrument Sans SemiBold" pitchFamily="34" charset="-122"/>
-                <a:cs typeface="Instrument Sans SemiBold" pitchFamily="34" charset="-120"/>
-              </a:rPr>
-              <a:t>Screen Readers &amp; TTS</a:t>
-            </a:r>
-            <a:endParaRPr lang="en-US" sz="1300" dirty="0"/>
-          </a:p>
-        </p:txBody>
-      </p:sp>
-      <p:sp>
-        <p:nvSpPr>
-          <p:cNvPr id="13" name="Text 8"/>
-          <p:cNvSpPr/>
-          <p:nvPr/>
-        </p:nvSpPr>
-        <p:spPr>
-          <a:xfrm>
-            <a:off x="661475" y="3864570"/>
-            <a:ext cx="3594308" cy="719931"/>
-          </a:xfrm>
-          <a:prstGeom prst="rect">
-            <a:avLst/>
-          </a:prstGeom>
-          <a:noFill/>
-          <a:ln/>
-        </p:spPr>
-        <p:txBody>
-          <a:bodyPr wrap="square" lIns="0" tIns="0" rIns="0" bIns="0" rtlCol="0" anchor="t">
-            <a:normAutofit/>
-          </a:bodyPr>
-          <a:lstStyle/>
-          <a:p>
-            <a:pPr algn="l" indent="0" marL="0">
-              <a:lnSpc>
-                <a:spcPct val="113000"/>
-              </a:lnSpc>
-              <a:buNone/>
-            </a:pPr>
-            <a:r>
-              <a:rPr lang="en-US" sz="1000" dirty="0">
-                <a:solidFill>
-                  <a:srgbClr val="1E3063"/>
-                </a:solidFill>
-                <a:latin typeface="Instrument Sans Medium" pitchFamily="34" charset="0"/>
-                <a:ea typeface="Instrument Sans Medium" pitchFamily="34" charset="-122"/>
-                <a:cs typeface="Instrument Sans Medium" pitchFamily="34" charset="-120"/>
-              </a:rPr>
-              <a:t>Complete Semantics(...) metadata for every control, map layer and camera viewfinder. Built‑in TTS for emergency alerts and hazard updates. Fluid typography adapts to system scaling without clipping.</a:t>
-            </a:r>
-            <a:endParaRPr lang="en-US" sz="1000" dirty="0"/>
+              <a:t>One‑tap switching between English, हिंदी (Hindi) and മലയാളം (Malayalam). Full localization across 19 civic categories; extended support for 22 scheduled languages with native typography.</a:t>
+            </a:r>
+            <a:endParaRPr lang="hi-IN" sz="1000" dirty="0"/>
           </a:p>
         </p:txBody>
       </p:sp>
       <p:pic>
         <p:nvPicPr>
-          <p:cNvPr id="14" name="Image 3" descr="preencoded.png">    </p:cNvPr>
+          <p:cNvPr id="6" name="Image 1" descr="preencoded.png"/>
           <p:cNvPicPr>
             <a:picLocks noChangeAspect="1"/>
           </p:cNvPicPr>
@@ -5409,8 +4920,8 @@
         </p:blipFill>
         <p:spPr>
           <a:xfrm>
-            <a:off x="5627547" y="2691606"/>
-            <a:ext cx="4866161" cy="2757488"/>
+            <a:off x="4322952" y="1294408"/>
+            <a:ext cx="719715" cy="899616"/>
           </a:xfrm>
           <a:prstGeom prst="rect">
             <a:avLst/>
@@ -5419,29 +4930,117 @@
       </p:pic>
       <p:sp>
         <p:nvSpPr>
-          <p:cNvPr id="15" name="Shape 9"/>
-          <p:cNvSpPr/>
-          <p:nvPr/>
-        </p:nvSpPr>
-        <p:spPr>
-          <a:xfrm>
-            <a:off x="661475" y="5657453"/>
-            <a:ext cx="10868745" cy="421977"/>
-          </a:xfrm>
-          <a:prstGeom prst="roundRect">
-            <a:avLst>
-              <a:gd name="adj" fmla="val 28220"/>
-            </a:avLst>
-          </a:prstGeom>
-          <a:solidFill>
-            <a:srgbClr val="CEE6FD"/>
-          </a:solidFill>
-          <a:ln/>
-        </p:spPr>
+          <p:cNvPr id="7" name="Text 3"/>
+          <p:cNvSpPr/>
+          <p:nvPr/>
+        </p:nvSpPr>
+        <p:spPr>
+          <a:xfrm>
+            <a:off x="5158353" y="1294408"/>
+            <a:ext cx="2710390" cy="413345"/>
+          </a:xfrm>
+          <a:prstGeom prst="rect">
+            <a:avLst/>
+          </a:prstGeom>
+          <a:noFill/>
+          <a:ln/>
+        </p:spPr>
+        <p:txBody>
+          <a:bodyPr wrap="square" lIns="0" tIns="0" rIns="0" bIns="0" rtlCol="0" anchor="t">
+            <a:normAutofit/>
+          </a:bodyPr>
+          <a:lstStyle/>
+          <a:p>
+            <a:pPr marL="0" indent="0" algn="l">
+              <a:lnSpc>
+                <a:spcPct val="104000"/>
+              </a:lnSpc>
+              <a:buNone/>
+            </a:pPr>
+            <a:r>
+              <a:rPr lang="en-US" sz="1300" dirty="0">
+                <a:solidFill>
+                  <a:srgbClr val="1E3063"/>
+                </a:solidFill>
+                <a:latin typeface="Instrument Sans SemiBold" pitchFamily="34" charset="0"/>
+                <a:ea typeface="Instrument Sans SemiBold" pitchFamily="34" charset="-122"/>
+                <a:cs typeface="Instrument Sans SemiBold" pitchFamily="34" charset="-120"/>
+              </a:rPr>
+              <a:t>WCAG AAA Dark Glassmorphic Aesthetics</a:t>
+            </a:r>
+            <a:endParaRPr lang="en-US" sz="1300" dirty="0"/>
+          </a:p>
+        </p:txBody>
+      </p:sp>
+      <p:sp>
+        <p:nvSpPr>
+          <p:cNvPr id="8" name="Text 4"/>
+          <p:cNvSpPr/>
+          <p:nvPr/>
+        </p:nvSpPr>
+        <p:spPr>
+          <a:xfrm>
+            <a:off x="5158353" y="1763316"/>
+            <a:ext cx="2710390" cy="719931"/>
+          </a:xfrm>
+          <a:prstGeom prst="rect">
+            <a:avLst/>
+          </a:prstGeom>
+          <a:noFill/>
+          <a:ln/>
+        </p:spPr>
+        <p:txBody>
+          <a:bodyPr wrap="square" lIns="0" tIns="0" rIns="0" bIns="0" rtlCol="0" anchor="t">
+            <a:normAutofit/>
+          </a:bodyPr>
+          <a:lstStyle/>
+          <a:p>
+            <a:pPr marL="0" indent="0" algn="l">
+              <a:lnSpc>
+                <a:spcPct val="113000"/>
+              </a:lnSpc>
+              <a:buNone/>
+            </a:pPr>
+            <a:r>
+              <a:rPr lang="en-US" sz="1000" dirty="0">
+                <a:solidFill>
+                  <a:srgbClr val="1E3063"/>
+                </a:solidFill>
+                <a:latin typeface="Instrument Sans Medium" pitchFamily="34" charset="0"/>
+                <a:ea typeface="Instrument Sans Medium" pitchFamily="34" charset="-122"/>
+                <a:cs typeface="Instrument Sans Medium" pitchFamily="34" charset="-120"/>
+              </a:rPr>
+              <a:t>Deep backgrounds with luminous accents ensure legibility in harsh daylight and night. Palette tuned for accessibility and brand: </a:t>
+            </a:r>
+            <a:r>
+              <a:rPr lang="en-US" sz="1000" dirty="0">
+                <a:solidFill>
+                  <a:srgbClr val="84C1FA"/>
+                </a:solidFill>
+                <a:latin typeface="Instrument Sans Medium" pitchFamily="34" charset="0"/>
+                <a:ea typeface="Instrument Sans Medium" pitchFamily="34" charset="-122"/>
+                <a:cs typeface="Instrument Sans Medium" pitchFamily="34" charset="-120"/>
+              </a:rPr>
+              <a:t>#84C1FA</a:t>
+            </a:r>
+            <a:r>
+              <a:rPr lang="en-US" sz="1000" dirty="0">
+                <a:solidFill>
+                  <a:srgbClr val="1E3063"/>
+                </a:solidFill>
+                <a:latin typeface="Instrument Sans Medium" pitchFamily="34" charset="0"/>
+                <a:ea typeface="Instrument Sans Medium" pitchFamily="34" charset="-122"/>
+                <a:cs typeface="Instrument Sans Medium" pitchFamily="34" charset="-120"/>
+              </a:rPr>
+              <a:t> accent.</a:t>
+            </a:r>
+            <a:endParaRPr lang="en-US" sz="1000" dirty="0"/>
+          </a:p>
+        </p:txBody>
       </p:sp>
       <p:pic>
         <p:nvPicPr>
-          <p:cNvPr id="16" name="Image 4" descr="preencoded.png">    </p:cNvPr>
+          <p:cNvPr id="9" name="Image 2" descr="preencoded.png"/>
           <p:cNvPicPr>
             <a:picLocks noChangeAspect="1"/>
           </p:cNvPicPr>
@@ -5455,6 +5054,248 @@
         </p:blipFill>
         <p:spPr>
           <a:xfrm>
+            <a:off x="7984429" y="1294408"/>
+            <a:ext cx="719715" cy="899616"/>
+          </a:xfrm>
+          <a:prstGeom prst="rect">
+            <a:avLst/>
+          </a:prstGeom>
+        </p:spPr>
+      </p:pic>
+      <p:sp>
+        <p:nvSpPr>
+          <p:cNvPr id="10" name="Text 5"/>
+          <p:cNvSpPr/>
+          <p:nvPr/>
+        </p:nvSpPr>
+        <p:spPr>
+          <a:xfrm>
+            <a:off x="8819830" y="1294408"/>
+            <a:ext cx="2710390" cy="206673"/>
+          </a:xfrm>
+          <a:prstGeom prst="rect">
+            <a:avLst/>
+          </a:prstGeom>
+          <a:noFill/>
+          <a:ln/>
+        </p:spPr>
+        <p:txBody>
+          <a:bodyPr wrap="none" lIns="0" tIns="0" rIns="0" bIns="0" rtlCol="0" anchor="t"/>
+          <a:lstStyle/>
+          <a:p>
+            <a:pPr marL="0" indent="0" algn="l">
+              <a:lnSpc>
+                <a:spcPct val="104000"/>
+              </a:lnSpc>
+              <a:buNone/>
+            </a:pPr>
+            <a:r>
+              <a:rPr lang="en-US" sz="1300" dirty="0">
+                <a:solidFill>
+                  <a:srgbClr val="1E3063"/>
+                </a:solidFill>
+                <a:latin typeface="Instrument Sans SemiBold" pitchFamily="34" charset="0"/>
+                <a:ea typeface="Instrument Sans SemiBold" pitchFamily="34" charset="-122"/>
+                <a:cs typeface="Instrument Sans SemiBold" pitchFamily="34" charset="-120"/>
+              </a:rPr>
+              <a:t>Natural Motion &amp; Haptics</a:t>
+            </a:r>
+            <a:endParaRPr lang="en-US" sz="1300" dirty="0"/>
+          </a:p>
+        </p:txBody>
+      </p:sp>
+      <p:sp>
+        <p:nvSpPr>
+          <p:cNvPr id="11" name="Text 6"/>
+          <p:cNvSpPr/>
+          <p:nvPr/>
+        </p:nvSpPr>
+        <p:spPr>
+          <a:xfrm>
+            <a:off x="8819830" y="1556643"/>
+            <a:ext cx="2710390" cy="539948"/>
+          </a:xfrm>
+          <a:prstGeom prst="rect">
+            <a:avLst/>
+          </a:prstGeom>
+          <a:noFill/>
+          <a:ln/>
+        </p:spPr>
+        <p:txBody>
+          <a:bodyPr wrap="square" lIns="0" tIns="0" rIns="0" bIns="0" rtlCol="0" anchor="t">
+            <a:normAutofit/>
+          </a:bodyPr>
+          <a:lstStyle/>
+          <a:p>
+            <a:pPr marL="0" indent="0" algn="l">
+              <a:lnSpc>
+                <a:spcPct val="113000"/>
+              </a:lnSpc>
+              <a:buNone/>
+            </a:pPr>
+            <a:r>
+              <a:rPr lang="en-US" sz="1000" dirty="0">
+                <a:solidFill>
+                  <a:srgbClr val="1E3063"/>
+                </a:solidFill>
+                <a:latin typeface="Instrument Sans Medium" pitchFamily="34" charset="0"/>
+                <a:ea typeface="Instrument Sans Medium" pitchFamily="34" charset="-122"/>
+                <a:cs typeface="Instrument Sans Medium" pitchFamily="34" charset="-120"/>
+              </a:rPr>
+              <a:t>Emil Kowalski spring dynamics: tactile haptics and physical scaling on tap for predictable, humane interactions.</a:t>
+            </a:r>
+            <a:endParaRPr lang="en-US" sz="1000" dirty="0"/>
+          </a:p>
+        </p:txBody>
+      </p:sp>
+      <p:sp>
+        <p:nvSpPr>
+          <p:cNvPr id="12" name="Text 7"/>
+          <p:cNvSpPr/>
+          <p:nvPr/>
+        </p:nvSpPr>
+        <p:spPr>
+          <a:xfrm>
+            <a:off x="661475" y="3565327"/>
+            <a:ext cx="3594308" cy="206673"/>
+          </a:xfrm>
+          <a:prstGeom prst="rect">
+            <a:avLst/>
+          </a:prstGeom>
+          <a:noFill/>
+          <a:ln/>
+        </p:spPr>
+        <p:txBody>
+          <a:bodyPr wrap="none" lIns="0" tIns="0" rIns="0" bIns="0" rtlCol="0" anchor="t"/>
+          <a:lstStyle/>
+          <a:p>
+            <a:pPr marL="0" indent="0" algn="l">
+              <a:lnSpc>
+                <a:spcPct val="104000"/>
+              </a:lnSpc>
+              <a:buNone/>
+            </a:pPr>
+            <a:r>
+              <a:rPr lang="en-US" sz="1300" dirty="0">
+                <a:solidFill>
+                  <a:srgbClr val="091C53"/>
+                </a:solidFill>
+                <a:latin typeface="Instrument Sans SemiBold" pitchFamily="34" charset="0"/>
+                <a:ea typeface="Instrument Sans SemiBold" pitchFamily="34" charset="-122"/>
+                <a:cs typeface="Instrument Sans SemiBold" pitchFamily="34" charset="-120"/>
+              </a:rPr>
+              <a:t>Screen Readers &amp; TTS</a:t>
+            </a:r>
+            <a:endParaRPr lang="en-US" sz="1300" dirty="0"/>
+          </a:p>
+        </p:txBody>
+      </p:sp>
+      <p:sp>
+        <p:nvSpPr>
+          <p:cNvPr id="13" name="Text 8"/>
+          <p:cNvSpPr/>
+          <p:nvPr/>
+        </p:nvSpPr>
+        <p:spPr>
+          <a:xfrm>
+            <a:off x="661475" y="3864570"/>
+            <a:ext cx="3594308" cy="719931"/>
+          </a:xfrm>
+          <a:prstGeom prst="rect">
+            <a:avLst/>
+          </a:prstGeom>
+          <a:noFill/>
+          <a:ln/>
+        </p:spPr>
+        <p:txBody>
+          <a:bodyPr wrap="square" lIns="0" tIns="0" rIns="0" bIns="0" rtlCol="0" anchor="t">
+            <a:normAutofit/>
+          </a:bodyPr>
+          <a:lstStyle/>
+          <a:p>
+            <a:pPr marL="0" indent="0" algn="l">
+              <a:lnSpc>
+                <a:spcPct val="113000"/>
+              </a:lnSpc>
+              <a:buNone/>
+            </a:pPr>
+            <a:r>
+              <a:rPr lang="en-US" sz="1000" dirty="0">
+                <a:solidFill>
+                  <a:srgbClr val="1E3063"/>
+                </a:solidFill>
+                <a:latin typeface="Instrument Sans Medium" pitchFamily="34" charset="0"/>
+                <a:ea typeface="Instrument Sans Medium" pitchFamily="34" charset="-122"/>
+                <a:cs typeface="Instrument Sans Medium" pitchFamily="34" charset="-120"/>
+              </a:rPr>
+              <a:t>Complete Semantics(...) metadata for every control, map layer and camera viewfinder. Built‑in TTS for emergency alerts and hazard updates. Fluid typography adapts to system scaling without clipping.</a:t>
+            </a:r>
+            <a:endParaRPr lang="en-US" sz="1000" dirty="0"/>
+          </a:p>
+        </p:txBody>
+      </p:sp>
+      <p:pic>
+        <p:nvPicPr>
+          <p:cNvPr id="14" name="Image 3" descr="preencoded.png"/>
+          <p:cNvPicPr>
+            <a:picLocks noChangeAspect="1"/>
+          </p:cNvPicPr>
+          <p:nvPr/>
+        </p:nvPicPr>
+        <p:blipFill>
+          <a:blip r:embed="rId6"/>
+          <a:stretch>
+            <a:fillRect/>
+          </a:stretch>
+        </p:blipFill>
+        <p:spPr>
+          <a:xfrm>
+            <a:off x="5627547" y="2691606"/>
+            <a:ext cx="4866161" cy="2757488"/>
+          </a:xfrm>
+          <a:prstGeom prst="rect">
+            <a:avLst/>
+          </a:prstGeom>
+        </p:spPr>
+      </p:pic>
+      <p:sp>
+        <p:nvSpPr>
+          <p:cNvPr id="15" name="Shape 9"/>
+          <p:cNvSpPr/>
+          <p:nvPr/>
+        </p:nvSpPr>
+        <p:spPr>
+          <a:xfrm>
+            <a:off x="661475" y="5657453"/>
+            <a:ext cx="10868745" cy="421977"/>
+          </a:xfrm>
+          <a:prstGeom prst="roundRect">
+            <a:avLst>
+              <a:gd name="adj" fmla="val 28220"/>
+            </a:avLst>
+          </a:prstGeom>
+          <a:solidFill>
+            <a:srgbClr val="CEE6FD"/>
+          </a:solidFill>
+          <a:ln/>
+        </p:spPr>
+      </p:sp>
+      <p:pic>
+        <p:nvPicPr>
+          <p:cNvPr id="16" name="Image 4" descr="preencoded.png"/>
+          <p:cNvPicPr>
+            <a:picLocks noChangeAspect="1"/>
+          </p:cNvPicPr>
+          <p:nvPr/>
+        </p:nvPicPr>
+        <p:blipFill>
+          <a:blip r:embed="rId7"/>
+          <a:stretch>
+            <a:fillRect/>
+          </a:stretch>
+        </p:blipFill>
+        <p:spPr>
+          <a:xfrm>
             <a:off x="793730" y="5794276"/>
             <a:ext cx="165294" cy="132259"/>
           </a:xfrm>
@@ -5484,7 +5325,7 @@
           <a:bodyPr wrap="none" lIns="0" tIns="0" rIns="0" bIns="0" rtlCol="0" anchor="t"/>
           <a:lstStyle/>
           <a:p>
-            <a:pPr algn="l" indent="0" marL="0">
+            <a:pPr marL="0" indent="0" algn="l">
               <a:lnSpc>
                 <a:spcPct val="113000"/>
               </a:lnSpc>
@@ -5551,7 +5392,7 @@
           <a:bodyPr wrap="none" lIns="0" tIns="0" rIns="0" bIns="0" rtlCol="0" anchor="t"/>
           <a:lstStyle/>
           <a:p>
-            <a:pPr algn="l" indent="0" marL="0">
+            <a:pPr marL="0" indent="0" algn="l">
               <a:lnSpc>
                 <a:spcPct val="104000"/>
               </a:lnSpc>
@@ -5615,7 +5456,7 @@
           <a:bodyPr wrap="none" lIns="0" tIns="0" rIns="0" bIns="0" rtlCol="0" anchor="t"/>
           <a:lstStyle/>
           <a:p>
-            <a:pPr algn="l" indent="0" marL="0">
+            <a:pPr marL="0" indent="0" algn="l">
               <a:lnSpc>
                 <a:spcPct val="104000"/>
               </a:lnSpc>
@@ -5659,7 +5500,7 @@
           </a:bodyPr>
           <a:lstStyle/>
           <a:p>
-            <a:pPr algn="l" indent="0" marL="0">
+            <a:pPr marL="0" indent="0" algn="l">
               <a:lnSpc>
                 <a:spcPct val="123000"/>
               </a:lnSpc>
@@ -5725,7 +5566,7 @@
           </a:bodyPr>
           <a:lstStyle/>
           <a:p>
-            <a:pPr algn="l" indent="0" marL="0">
+            <a:pPr marL="0" indent="0" algn="l">
               <a:lnSpc>
                 <a:spcPct val="104000"/>
               </a:lnSpc>
@@ -5769,7 +5610,7 @@
           </a:bodyPr>
           <a:lstStyle/>
           <a:p>
-            <a:pPr algn="l" indent="0" marL="0">
+            <a:pPr marL="0" indent="0" algn="l">
               <a:lnSpc>
                 <a:spcPct val="123000"/>
               </a:lnSpc>
@@ -5833,7 +5674,7 @@
           <a:bodyPr wrap="none" lIns="0" tIns="0" rIns="0" bIns="0" rtlCol="0" anchor="t"/>
           <a:lstStyle/>
           <a:p>
-            <a:pPr algn="l" indent="0" marL="0">
+            <a:pPr marL="0" indent="0" algn="l">
               <a:lnSpc>
                 <a:spcPct val="104000"/>
               </a:lnSpc>
@@ -5877,7 +5718,7 @@
           </a:bodyPr>
           <a:lstStyle/>
           <a:p>
-            <a:pPr algn="l" indent="0" marL="0">
+            <a:pPr marL="0" indent="0" algn="l">
               <a:lnSpc>
                 <a:spcPct val="123000"/>
               </a:lnSpc>
@@ -5919,7 +5760,7 @@
           <a:bodyPr wrap="none" lIns="0" tIns="0" rIns="0" bIns="0" rtlCol="0" anchor="t"/>
           <a:lstStyle/>
           <a:p>
-            <a:pPr algn="l" indent="0" marL="0">
+            <a:pPr marL="0" indent="0" algn="l">
               <a:lnSpc>
                 <a:spcPct val="104000"/>
               </a:lnSpc>
@@ -5963,13 +5804,13 @@
           </a:bodyPr>
           <a:lstStyle/>
           <a:p>
-            <a:pPr algn="l" marL="254000" indent="-254000">
+            <a:pPr marL="254000" indent="-254000" algn="l">
               <a:lnSpc>
                 <a:spcPct val="123000"/>
               </a:lnSpc>
               <a:buSzPct val="100000"/>
               <a:buFont typeface="+mj-lt"/>
-              <a:buAutoNum type="arabicPeriod" startAt="1"/>
+              <a:buAutoNum type="arabicPeriod"/>
             </a:pPr>
             <a:r>
               <a:rPr lang="en-US" sz="1250" dirty="0">
@@ -5985,7 +5826,7 @@
             <a:endParaRPr lang="en-US" sz="1250" dirty="0"/>
           </a:p>
           <a:p>
-            <a:pPr algn="l" marL="254000" indent="-254000">
+            <a:pPr marL="254000" indent="-254000" algn="l">
               <a:lnSpc>
                 <a:spcPct val="123000"/>
               </a:lnSpc>
@@ -6007,7 +5848,7 @@
             <a:endParaRPr lang="en-US" sz="1250" dirty="0"/>
           </a:p>
           <a:p>
-            <a:pPr algn="l" marL="254000" indent="-254000">
+            <a:pPr marL="254000" indent="-254000" algn="l">
               <a:lnSpc>
                 <a:spcPct val="123000"/>
               </a:lnSpc>
@@ -6032,14 +5873,14 @@
       </p:sp>
       <p:pic>
         <p:nvPicPr>
-          <p:cNvPr id="14" name="Image 0" descr="preencoded.png">    </p:cNvPr>
+          <p:cNvPr id="14" name="Image 0" descr="preencoded.png"/>
           <p:cNvPicPr>
             <a:picLocks noChangeAspect="1"/>
           </p:cNvPicPr>
           <p:nvPr/>
         </p:nvPicPr>
         <p:blipFill>
-          <a:blip r:embed="rId1"/>
+          <a:blip r:embed="rId3"/>
           <a:stretch>
             <a:fillRect/>
           </a:stretch>
@@ -6077,7 +5918,7 @@
           </a:bodyPr>
           <a:lstStyle/>
           <a:p>
-            <a:pPr algn="l" indent="0" marL="0">
+            <a:pPr marL="0" indent="0" algn="l">
               <a:lnSpc>
                 <a:spcPct val="123000"/>
               </a:lnSpc>
@@ -6094,12 +5935,6 @@
               </a:rPr>
               <a:t>Deployment:</a:t>
             </a:r>
-            <a:pPr algn="l" indent="0" marL="0">
-              <a:lnSpc>
-                <a:spcPct val="123000"/>
-              </a:lnSpc>
-              <a:buNone/>
-            </a:pPr>
             <a:r>
               <a:rPr lang="en-US" sz="1250" dirty="0">
                 <a:solidFill>
@@ -6142,14 +5977,14 @@
       </p:grpSpPr>
       <p:pic>
         <p:nvPicPr>
-          <p:cNvPr id="2" name="Image 0" descr="">    </p:cNvPr>
+          <p:cNvPr id="2" name="Image 0"/>
           <p:cNvPicPr>
             <a:picLocks noChangeAspect="1"/>
           </p:cNvPicPr>
           <p:nvPr/>
         </p:nvPicPr>
         <p:blipFill>
-          <a:blip r:embed="rId1"/>
+          <a:blip r:embed="rId3"/>
           <a:stretch>
             <a:fillRect/>
           </a:stretch>
@@ -6269,7 +6104,7 @@
           <a:bodyPr wrap="none" lIns="0" tIns="0" rIns="0" bIns="0" rtlCol="0" anchor="t"/>
           <a:lstStyle/>
           <a:p>
-            <a:pPr algn="ctr" indent="0" marL="0">
+            <a:pPr marL="0" indent="0" algn="ctr">
               <a:lnSpc>
                 <a:spcPct val="104000"/>
               </a:lnSpc>
@@ -6313,7 +6148,7 @@
           </a:bodyPr>
           <a:lstStyle/>
           <a:p>
-            <a:pPr algn="l" indent="0" marL="0">
+            <a:pPr marL="0" indent="0" algn="l">
               <a:lnSpc>
                 <a:spcPct val="119000"/>
               </a:lnSpc>
@@ -6336,17 +6171,17 @@
       </p:sp>
       <p:pic>
         <p:nvPicPr>
-          <p:cNvPr id="5" name="Image 1" descr="preencoded.png">    </p:cNvPr>
+          <p:cNvPr id="5" name="Image 1" descr="preencoded.png"/>
           <p:cNvPicPr>
             <a:picLocks noChangeAspect="1"/>
           </p:cNvPicPr>
           <p:nvPr/>
         </p:nvPicPr>
         <p:blipFill>
-          <a:blip r:embed="rId2">
+          <a:blip>
             <a:extLst>
               <a:ext uri="{96DAC541-7B7A-43D3-8B79-37D633B846F1}">
-                <asvg:svgBlip xmlns:asvg="http://schemas.microsoft.com/office/drawing/2016/SVG/main" r:embed="rId3"/>
+                <asvg:svgBlip xmlns:asvg="http://schemas.microsoft.com/office/drawing/2016/SVG/main" r:embed="rId4"/>
               </a:ext>
             </a:extLst>
           </a:blip>
@@ -6385,7 +6220,7 @@
           <a:bodyPr wrap="none" lIns="0" tIns="0" rIns="0" bIns="0" rtlCol="0" anchor="t"/>
           <a:lstStyle/>
           <a:p>
-            <a:pPr algn="l" indent="0" marL="0">
+            <a:pPr marL="0" indent="0" algn="l">
               <a:lnSpc>
                 <a:spcPct val="104000"/>
               </a:lnSpc>
@@ -6427,7 +6262,7 @@
           <a:bodyPr wrap="none" lIns="0" tIns="0" rIns="0" bIns="0" rtlCol="0" anchor="t"/>
           <a:lstStyle/>
           <a:p>
-            <a:pPr algn="l" indent="0" marL="0">
+            <a:pPr marL="0" indent="0" algn="l">
               <a:lnSpc>
                 <a:spcPct val="119000"/>
               </a:lnSpc>
@@ -6450,14 +6285,14 @@
       </p:sp>
       <p:pic>
         <p:nvPicPr>
-          <p:cNvPr id="8" name="Image 2" descr="preencoded.png">    </p:cNvPr>
+          <p:cNvPr id="8" name="Image 2" descr="preencoded.png"/>
           <p:cNvPicPr>
             <a:picLocks noChangeAspect="1"/>
           </p:cNvPicPr>
           <p:nvPr/>
         </p:nvPicPr>
         <p:blipFill>
-          <a:blip r:embed="rId4">
+          <a:blip>
             <a:extLst>
               <a:ext uri="{96DAC541-7B7A-43D3-8B79-37D633B846F1}">
                 <asvg:svgBlip xmlns:asvg="http://schemas.microsoft.com/office/drawing/2016/SVG/main" r:embed="rId5"/>
@@ -6499,7 +6334,7 @@
           <a:bodyPr wrap="none" lIns="0" tIns="0" rIns="0" bIns="0" rtlCol="0" anchor="t"/>
           <a:lstStyle/>
           <a:p>
-            <a:pPr algn="l" indent="0" marL="0">
+            <a:pPr marL="0" indent="0" algn="l">
               <a:lnSpc>
                 <a:spcPct val="104000"/>
               </a:lnSpc>
@@ -6541,7 +6376,7 @@
           <a:bodyPr wrap="none" lIns="0" tIns="0" rIns="0" bIns="0" rtlCol="0" anchor="t"/>
           <a:lstStyle/>
           <a:p>
-            <a:pPr algn="l" indent="0" marL="0">
+            <a:pPr marL="0" indent="0" algn="l">
               <a:lnSpc>
                 <a:spcPct val="119000"/>
               </a:lnSpc>
@@ -6564,17 +6399,17 @@
       </p:sp>
       <p:pic>
         <p:nvPicPr>
-          <p:cNvPr id="11" name="Image 3" descr="preencoded.png">    </p:cNvPr>
+          <p:cNvPr id="11" name="Image 3" descr="preencoded.png"/>
           <p:cNvPicPr>
             <a:picLocks noChangeAspect="1"/>
           </p:cNvPicPr>
           <p:nvPr/>
         </p:nvPicPr>
         <p:blipFill>
-          <a:blip r:embed="rId6">
+          <a:blip>
             <a:extLst>
               <a:ext uri="{96DAC541-7B7A-43D3-8B79-37D633B846F1}">
-                <asvg:svgBlip xmlns:asvg="http://schemas.microsoft.com/office/drawing/2016/SVG/main" r:embed="rId7"/>
+                <asvg:svgBlip xmlns:asvg="http://schemas.microsoft.com/office/drawing/2016/SVG/main" r:embed="rId6"/>
               </a:ext>
             </a:extLst>
           </a:blip>
@@ -6613,7 +6448,7 @@
           <a:bodyPr wrap="none" lIns="0" tIns="0" rIns="0" bIns="0" rtlCol="0" anchor="t"/>
           <a:lstStyle/>
           <a:p>
-            <a:pPr algn="l" indent="0" marL="0">
+            <a:pPr marL="0" indent="0" algn="l">
               <a:lnSpc>
                 <a:spcPct val="104000"/>
               </a:lnSpc>
@@ -6655,7 +6490,7 @@
           <a:bodyPr wrap="none" lIns="0" tIns="0" rIns="0" bIns="0" rtlCol="0" anchor="t"/>
           <a:lstStyle/>
           <a:p>
-            <a:pPr algn="l" indent="0" marL="0">
+            <a:pPr marL="0" indent="0" algn="l">
               <a:lnSpc>
                 <a:spcPct val="119000"/>
               </a:lnSpc>
@@ -6700,14 +6535,14 @@
       </p:sp>
       <p:pic>
         <p:nvPicPr>
-          <p:cNvPr id="15" name="Image 4" descr="preencoded.png">    </p:cNvPr>
+          <p:cNvPr id="15" name="Image 4" descr="preencoded.png"/>
           <p:cNvPicPr>
             <a:picLocks noChangeAspect="1"/>
           </p:cNvPicPr>
           <p:nvPr/>
         </p:nvPicPr>
         <p:blipFill>
-          <a:blip r:embed="rId8"/>
+          <a:blip r:embed="rId7"/>
           <a:stretch>
             <a:fillRect/>
           </a:stretch>
@@ -6745,7 +6580,7 @@
           </a:bodyPr>
           <a:lstStyle/>
           <a:p>
-            <a:pPr algn="l" indent="0" marL="0">
+            <a:pPr marL="0" indent="0" algn="l">
               <a:lnSpc>
                 <a:spcPct val="119000"/>
               </a:lnSpc>
@@ -7067,4 +6902,319 @@
     </a:ext>
   </a:extLst>
 </a:theme>
+</file>
+
+<file path=ppt/theme/theme2.xml><?xml version="1.0" encoding="utf-8"?>
+<a:theme xmlns:a="http://schemas.openxmlformats.org/drawingml/2006/main" name="Office Theme">
+  <a:themeElements>
+    <a:clrScheme name="Office">
+      <a:dk1>
+        <a:sysClr val="windowText" lastClr="000000"/>
+      </a:dk1>
+      <a:lt1>
+        <a:sysClr val="window" lastClr="FFFFFF"/>
+      </a:lt1>
+      <a:dk2>
+        <a:srgbClr val="0E2841"/>
+      </a:dk2>
+      <a:lt2>
+        <a:srgbClr val="E8E8E8"/>
+      </a:lt2>
+      <a:accent1>
+        <a:srgbClr val="156082"/>
+      </a:accent1>
+      <a:accent2>
+        <a:srgbClr val="E97132"/>
+      </a:accent2>
+      <a:accent3>
+        <a:srgbClr val="196B24"/>
+      </a:accent3>
+      <a:accent4>
+        <a:srgbClr val="0F9ED5"/>
+      </a:accent4>
+      <a:accent5>
+        <a:srgbClr val="A02B93"/>
+      </a:accent5>
+      <a:accent6>
+        <a:srgbClr val="4EA72E"/>
+      </a:accent6>
+      <a:hlink>
+        <a:srgbClr val="467886"/>
+      </a:hlink>
+      <a:folHlink>
+        <a:srgbClr val="96607D"/>
+      </a:folHlink>
+    </a:clrScheme>
+    <a:fontScheme name="Office">
+      <a:majorFont>
+        <a:latin typeface="Aptos Display" panose="02110004020202020204"/>
+        <a:ea typeface=""/>
+        <a:cs typeface=""/>
+        <a:font script="Jpan" typeface="游ゴシック Light"/>
+        <a:font script="Hang" typeface="맑은 고딕"/>
+        <a:font script="Hans" typeface="等线 Light"/>
+        <a:font script="Hant" typeface="新細明體"/>
+        <a:font script="Arab" typeface="Times New Roman"/>
+        <a:font script="Hebr" typeface="Times New Roman"/>
+        <a:font script="Thai" typeface="Angsana New"/>
+        <a:font script="Ethi" typeface="Nyala"/>
+        <a:font script="Beng" typeface="Vrinda"/>
+        <a:font script="Gujr" typeface="Shruti"/>
+        <a:font script="Khmr" typeface="MoolBoran"/>
+        <a:font script="Knda" typeface="Tunga"/>
+        <a:font script="Guru" typeface="Raavi"/>
+        <a:font script="Cans" typeface="Euphemia"/>
+        <a:font script="Cher" typeface="Plantagenet Cherokee"/>
+        <a:font script="Yiii" typeface="Microsoft Yi Baiti"/>
+        <a:font script="Tibt" typeface="Microsoft Himalaya"/>
+        <a:font script="Thaa" typeface="MV Boli"/>
+        <a:font script="Deva" typeface="Mangal"/>
+        <a:font script="Telu" typeface="Gautami"/>
+        <a:font script="Taml" typeface="Latha"/>
+        <a:font script="Syrc" typeface="Estrangelo Edessa"/>
+        <a:font script="Orya" typeface="Kalinga"/>
+        <a:font script="Mlym" typeface="Kartika"/>
+        <a:font script="Laoo" typeface="DokChampa"/>
+        <a:font script="Sinh" typeface="Iskoola Pota"/>
+        <a:font script="Mong" typeface="Mongolian Baiti"/>
+        <a:font script="Viet" typeface="Times New Roman"/>
+        <a:font script="Uigh" typeface="Microsoft Uighur"/>
+        <a:font script="Geor" typeface="Sylfaen"/>
+        <a:font script="Armn" typeface="Arial"/>
+        <a:font script="Bugi" typeface="Leelawadee UI"/>
+        <a:font script="Bopo" typeface="Microsoft JhengHei"/>
+        <a:font script="Java" typeface="Javanese Text"/>
+        <a:font script="Lisu" typeface="Segoe UI"/>
+        <a:font script="Mymr" typeface="Myanmar Text"/>
+        <a:font script="Nkoo" typeface="Ebrima"/>
+        <a:font script="Olck" typeface="Nirmala UI"/>
+        <a:font script="Osma" typeface="Ebrima"/>
+        <a:font script="Phag" typeface="Phagspa"/>
+        <a:font script="Syrn" typeface="Estrangelo Edessa"/>
+        <a:font script="Syrj" typeface="Estrangelo Edessa"/>
+        <a:font script="Syre" typeface="Estrangelo Edessa"/>
+        <a:font script="Sora" typeface="Nirmala UI"/>
+        <a:font script="Tale" typeface="Microsoft Tai Le"/>
+        <a:font script="Talu" typeface="Microsoft New Tai Lue"/>
+        <a:font script="Tfng" typeface="Ebrima"/>
+      </a:majorFont>
+      <a:minorFont>
+        <a:latin typeface="Aptos" panose="02110004020202020204"/>
+        <a:ea typeface=""/>
+        <a:cs typeface=""/>
+        <a:font script="Jpan" typeface="游ゴシック"/>
+        <a:font script="Hang" typeface="맑은 고딕"/>
+        <a:font script="Hans" typeface="等线"/>
+        <a:font script="Hant" typeface="新細明體"/>
+        <a:font script="Arab" typeface="Arial"/>
+        <a:font script="Hebr" typeface="Arial"/>
+        <a:font script="Thai" typeface="Cordia New"/>
+        <a:font script="Ethi" typeface="Nyala"/>
+        <a:font script="Beng" typeface="Vrinda"/>
+        <a:font script="Gujr" typeface="Shruti"/>
+        <a:font script="Khmr" typeface="DaunPenh"/>
+        <a:font script="Knda" typeface="Tunga"/>
+        <a:font script="Guru" typeface="Raavi"/>
+        <a:font script="Cans" typeface="Euphemia"/>
+        <a:font script="Cher" typeface="Plantagenet Cherokee"/>
+        <a:font script="Yiii" typeface="Microsoft Yi Baiti"/>
+        <a:font script="Tibt" typeface="Microsoft Himalaya"/>
+        <a:font script="Thaa" typeface="MV Boli"/>
+        <a:font script="Deva" typeface="Mangal"/>
+        <a:font script="Telu" typeface="Gautami"/>
+        <a:font script="Taml" typeface="Latha"/>
+        <a:font script="Syrc" typeface="Estrangelo Edessa"/>
+        <a:font script="Orya" typeface="Kalinga"/>
+        <a:font script="Mlym" typeface="Kartika"/>
+        <a:font script="Laoo" typeface="DokChampa"/>
+        <a:font script="Sinh" typeface="Iskoola Pota"/>
+        <a:font script="Mong" typeface="Mongolian Baiti"/>
+        <a:font script="Viet" typeface="Arial"/>
+        <a:font script="Uigh" typeface="Microsoft Uighur"/>
+        <a:font script="Geor" typeface="Sylfaen"/>
+        <a:font script="Armn" typeface="Arial"/>
+        <a:font script="Bugi" typeface="Leelawadee UI"/>
+        <a:font script="Bopo" typeface="Microsoft JhengHei"/>
+        <a:font script="Java" typeface="Javanese Text"/>
+        <a:font script="Lisu" typeface="Segoe UI"/>
+        <a:font script="Mymr" typeface="Myanmar Text"/>
+        <a:font script="Nkoo" typeface="Ebrima"/>
+        <a:font script="Olck" typeface="Nirmala UI"/>
+        <a:font script="Osma" typeface="Ebrima"/>
+        <a:font script="Phag" typeface="Phagspa"/>
+        <a:font script="Syrn" typeface="Estrangelo Edessa"/>
+        <a:font script="Syrj" typeface="Estrangelo Edessa"/>
+        <a:font script="Syre" typeface="Estrangelo Edessa"/>
+        <a:font script="Sora" typeface="Nirmala UI"/>
+        <a:font script="Tale" typeface="Microsoft Tai Le"/>
+        <a:font script="Talu" typeface="Microsoft New Tai Lue"/>
+        <a:font script="Tfng" typeface="Ebrima"/>
+      </a:minorFont>
+    </a:fontScheme>
+    <a:fmtScheme name="Office">
+      <a:fillStyleLst>
+        <a:solidFill>
+          <a:schemeClr val="phClr"/>
+        </a:solidFill>
+        <a:gradFill rotWithShape="1">
+          <a:gsLst>
+            <a:gs pos="0">
+              <a:schemeClr val="phClr">
+                <a:lumMod val="110000"/>
+                <a:satMod val="105000"/>
+                <a:tint val="67000"/>
+              </a:schemeClr>
+            </a:gs>
+            <a:gs pos="50000">
+              <a:schemeClr val="phClr">
+                <a:lumMod val="105000"/>
+                <a:satMod val="103000"/>
+                <a:tint val="73000"/>
+              </a:schemeClr>
+            </a:gs>
+            <a:gs pos="100000">
+              <a:schemeClr val="phClr">
+                <a:lumMod val="105000"/>
+                <a:satMod val="109000"/>
+                <a:tint val="81000"/>
+              </a:schemeClr>
+            </a:gs>
+          </a:gsLst>
+          <a:lin ang="5400000" scaled="0"/>
+        </a:gradFill>
+        <a:gradFill rotWithShape="1">
+          <a:gsLst>
+            <a:gs pos="0">
+              <a:schemeClr val="phClr">
+                <a:satMod val="103000"/>
+                <a:lumMod val="102000"/>
+                <a:tint val="94000"/>
+              </a:schemeClr>
+            </a:gs>
+            <a:gs pos="50000">
+              <a:schemeClr val="phClr">
+                <a:satMod val="110000"/>
+                <a:lumMod val="100000"/>
+                <a:shade val="100000"/>
+              </a:schemeClr>
+            </a:gs>
+            <a:gs pos="100000">
+              <a:schemeClr val="phClr">
+                <a:lumMod val="99000"/>
+                <a:satMod val="120000"/>
+                <a:shade val="78000"/>
+              </a:schemeClr>
+            </a:gs>
+          </a:gsLst>
+          <a:lin ang="5400000" scaled="0"/>
+        </a:gradFill>
+      </a:fillStyleLst>
+      <a:lnStyleLst>
+        <a:ln w="12700" cap="flat" cmpd="sng" algn="ctr">
+          <a:solidFill>
+            <a:schemeClr val="phClr"/>
+          </a:solidFill>
+          <a:prstDash val="solid"/>
+          <a:miter lim="800000"/>
+        </a:ln>
+        <a:ln w="19050" cap="flat" cmpd="sng" algn="ctr">
+          <a:solidFill>
+            <a:schemeClr val="phClr"/>
+          </a:solidFill>
+          <a:prstDash val="solid"/>
+          <a:miter lim="800000"/>
+        </a:ln>
+        <a:ln w="25400" cap="flat" cmpd="sng" algn="ctr">
+          <a:solidFill>
+            <a:schemeClr val="phClr"/>
+          </a:solidFill>
+          <a:prstDash val="solid"/>
+          <a:miter lim="800000"/>
+        </a:ln>
+      </a:lnStyleLst>
+      <a:effectStyleLst>
+        <a:effectStyle>
+          <a:effectLst/>
+        </a:effectStyle>
+        <a:effectStyle>
+          <a:effectLst/>
+        </a:effectStyle>
+        <a:effectStyle>
+          <a:effectLst>
+            <a:outerShdw blurRad="57150" dist="19050" dir="5400000" algn="ctr" rotWithShape="0">
+              <a:srgbClr val="000000">
+                <a:alpha val="63000"/>
+              </a:srgbClr>
+            </a:outerShdw>
+          </a:effectLst>
+        </a:effectStyle>
+      </a:effectStyleLst>
+      <a:bgFillStyleLst>
+        <a:solidFill>
+          <a:schemeClr val="phClr"/>
+        </a:solidFill>
+        <a:solidFill>
+          <a:schemeClr val="phClr">
+            <a:tint val="95000"/>
+            <a:satMod val="170000"/>
+          </a:schemeClr>
+        </a:solidFill>
+        <a:gradFill rotWithShape="1">
+          <a:gsLst>
+            <a:gs pos="0">
+              <a:schemeClr val="phClr">
+                <a:tint val="93000"/>
+                <a:satMod val="150000"/>
+                <a:shade val="98000"/>
+                <a:lumMod val="102000"/>
+              </a:schemeClr>
+            </a:gs>
+            <a:gs pos="50000">
+              <a:schemeClr val="phClr">
+                <a:tint val="98000"/>
+                <a:satMod val="130000"/>
+                <a:shade val="90000"/>
+                <a:lumMod val="103000"/>
+              </a:schemeClr>
+            </a:gs>
+            <a:gs pos="100000">
+              <a:schemeClr val="phClr">
+                <a:shade val="63000"/>
+                <a:satMod val="120000"/>
+              </a:schemeClr>
+            </a:gs>
+          </a:gsLst>
+          <a:lin ang="5400000" scaled="0"/>
+        </a:gradFill>
+      </a:bgFillStyleLst>
+    </a:fmtScheme>
+  </a:themeElements>
+  <a:objectDefaults>
+    <a:lnDef>
+      <a:spPr/>
+      <a:bodyPr/>
+      <a:lstStyle/>
+      <a:style>
+        <a:lnRef idx="2">
+          <a:schemeClr val="accent1"/>
+        </a:lnRef>
+        <a:fillRef idx="0">
+          <a:schemeClr val="accent1"/>
+        </a:fillRef>
+        <a:effectRef idx="1">
+          <a:schemeClr val="accent1"/>
+        </a:effectRef>
+        <a:fontRef idx="minor">
+          <a:schemeClr val="tx1"/>
+        </a:fontRef>
+      </a:style>
+    </a:lnDef>
+  </a:objectDefaults>
+  <a:extraClrSchemeLst/>
+  <a:extLst>
+    <a:ext uri="{05A4C25C-085E-4340-85A3-A5531E510DB2}">
+      <thm15:themeFamily xmlns:thm15="http://schemas.microsoft.com/office/thememl/2012/main" name="Office Theme" id="{2E142A2C-CD16-42D6-873A-C26D2A0506FA}" vid="{1BDDFF52-6CD6-40A5-AB3C-68EB2F1E4D0A}"/>
+    </a:ext>
+  </a:extLst>
+</a:theme>
 </file>
</xml_diff>